<commit_message>
docs: add comprehensive 50-question Grand Finale hardware viva defense guide and apply bulletproof pitch refinements to v7 deck
</commit_message>
<xml_diff>
--- a/Copy of SIH26177_v7.pptx.pptx
+++ b/Copy of SIH26177_v7.pptx.pptx
@@ -13109,87 +13109,87 @@
                 </a:solidFill>
                 <a:latin typeface="Calibri"/>
               </a:rPr>
-              <a:t>IN CATASTROPHIC DISASTERS (LANDSLIDES, EARTHQUAKES), FIRST RESPONDERS FACE FOUR CRITICAL BARRIERS:</a:t>
+              <a:t>CRITICAL DISASTER BARRIERS — FOUR OPERATIONAL FAILURES:</a:t>
             </a:r>
           </a:p>
           <a:p>
             <a:r>
-              <a:rPr sz="1400" b="1" i="0">
+              <a:rPr sz="1350" b="1" i="0">
                 <a:solidFill>
                   <a:srgbClr val="1E2638"/>
                 </a:solidFill>
                 <a:latin typeface="Calibri"/>
               </a:rPr>
-              <a:t>COMMS BLACKOUT: </a:t>
+              <a:t>01 — CONNECTIVITY: </a:t>
             </a:r>
             <a:r>
-              <a:rPr sz="1400" b="0" i="0">
+              <a:rPr sz="1350" b="0" i="0">
                 <a:solidFill>
                   <a:srgbClr val="1E2638"/>
                 </a:solidFill>
                 <a:latin typeface="Calibri"/>
               </a:rPr>
-              <a:t>Downed cellular towers &amp; power grids; cloud-dependent drones rendered completely inoperable.</a:t>
+              <a:t>Cellular and power infrastructure may be unavailable; cloud-dependent drones rendered completely inoperable.</a:t>
             </a:r>
           </a:p>
           <a:p>
             <a:r>
-              <a:rPr sz="1400" b="1" i="0">
+              <a:rPr sz="1350" b="1" i="0">
                 <a:solidFill>
                   <a:srgbClr val="1E2638"/>
                 </a:solidFill>
                 <a:latin typeface="Calibri"/>
               </a:rPr>
-              <a:t>ZERO VISIBILITY: </a:t>
+              <a:t>02 — VISIBILITY: </a:t>
             </a:r>
             <a:r>
-              <a:rPr sz="1400" b="0" i="0">
+              <a:rPr sz="1350" b="0" i="0">
                 <a:solidFill>
                   <a:srgbClr val="1E2638"/>
                 </a:solidFill>
                 <a:latin typeface="Calibri"/>
               </a:rPr>
-              <a:t>Mud slush, dense smoke, and darkness blind standard visual electro-optical cameras.</a:t>
+              <a:t>Darkness, smoke and dense debris severely constrain conventional RGB electro-optical observation.</a:t>
             </a:r>
           </a:p>
           <a:p>
             <a:r>
-              <a:rPr sz="1400" b="1" i="0">
+              <a:rPr sz="1350" b="1" i="0">
                 <a:solidFill>
                   <a:srgbClr val="1E2638"/>
                 </a:solidFill>
                 <a:latin typeface="Calibri"/>
               </a:rPr>
-              <a:t>ENTRAPMENT ACCESS: </a:t>
+              <a:t>03 — LOCALIZATION: </a:t>
             </a:r>
             <a:r>
-              <a:rPr sz="1400" b="0" i="0">
+              <a:rPr sz="1350" b="0" i="0">
                 <a:solidFill>
                   <a:srgbClr val="1E2638"/>
                 </a:solidFill>
                 <a:latin typeface="Calibri"/>
               </a:rPr>
-              <a:t>Survivability sharply declines with delayed response; manual foot searches cannot cover wide rubble sectors in time.</a:t>
+              <a:t>Spotting a casualty is not enough; rescue teams require precise, actionable ground GPS coordinates.</a:t>
             </a:r>
           </a:p>
           <a:p>
             <a:r>
-              <a:rPr sz="1400" b="1" i="0">
+              <a:rPr sz="1350" b="1" i="0">
                 <a:solidFill>
                   <a:srgbClr val="1E2638"/>
                 </a:solidFill>
                 <a:latin typeface="Calibri"/>
               </a:rPr>
-              <a:t>RESPONDER HAZARDS: </a:t>
+              <a:t>04 — ACCESS: </a:t>
             </a:r>
             <a:r>
-              <a:rPr sz="1400" b="0" i="0">
+              <a:rPr sz="1350" b="0" i="0">
                 <a:solidFill>
                   <a:srgbClr val="1E2638"/>
                 </a:solidFill>
                 <a:latin typeface="Calibri"/>
               </a:rPr>
-              <a:t>Ground teams advance blindly toward fallen electrical wires, gas leaks, and secondary landslides.</a:t>
+              <a:t>Secondary hazards (electrical lines, shifting rubble, gas voids) make direct rescue paths dangerous.</a:t>
             </a:r>
           </a:p>
         </p:txBody>
@@ -13227,87 +13227,87 @@
                 </a:solidFill>
                 <a:latin typeface="Calibri"/>
               </a:rPr>
-              <a:t>Project Phoenix: An autonomous, field-deployable multirotor scout engineered for offline disaster zones:</a:t>
+              <a:t>Project Phoenix: Autonomous, field-deployable multirotor closing the aerial-to-ground rescue loop:</a:t>
             </a:r>
           </a:p>
           <a:p>
             <a:r>
-              <a:rPr sz="1400" b="1" i="0">
+              <a:rPr sz="1350" b="1" i="0">
                 <a:solidFill>
                   <a:srgbClr val="1E2638"/>
                 </a:solidFill>
                 <a:latin typeface="Calibri"/>
               </a:rPr>
-              <a:t>100% ONBOARD EDGE COMPUTE: </a:t>
+              <a:t>DUAL-BRAIN HARDWARE SPLIT: </a:t>
             </a:r>
             <a:r>
-              <a:rPr sz="1400" b="0" i="0">
+              <a:rPr sz="1350" b="0" i="0">
                 <a:solidFill>
                   <a:srgbClr val="1E2638"/>
                 </a:solidFill>
                 <a:latin typeface="Calibri"/>
               </a:rPr>
-              <a:t>Heterogeneous AI (CPU/GPU/DSP) executes all vision &amp; geolocation on-device; zero cloud/cellular dependency.</a:t>
+              <a:t>QRB2210 MPU performs INT8 edge-AI on Linux; STM32U585 MCU runs deterministic 250 Hz flight loop on Zephyr.</a:t>
             </a:r>
           </a:p>
           <a:p>
             <a:r>
-              <a:rPr sz="1400" b="1" i="0">
+              <a:rPr sz="1350" b="1" i="0">
                 <a:solidFill>
                   <a:srgbClr val="1E2638"/>
                 </a:solidFill>
                 <a:latin typeface="Calibri"/>
               </a:rPr>
-              <a:t>MULTI-SPECTRAL FUSION: </a:t>
+              <a:t>MULTIMODAL PERCEPTION: </a:t>
             </a:r>
             <a:r>
-              <a:rPr sz="1400" b="0" i="0">
+              <a:rPr sz="1350" b="0" i="0">
                 <a:solidFill>
                   <a:srgbClr val="1E2638"/>
                 </a:solidFill>
                 <a:latin typeface="Calibri"/>
               </a:rPr>
-              <a:t>Combines 4K RGB with LWIR Thermal (8-14μm) to spot surface heat anomalies &amp; exposed casualties through smoke/darkness.</a:t>
+              <a:t>Fuses 4K RGB + LWIR thermal (8–14μm) to detect human heat signatures in darkness, smoke &amp; partially exposed debris.</a:t>
             </a:r>
           </a:p>
           <a:p>
             <a:r>
-              <a:rPr sz="1400" b="1" i="0">
+              <a:rPr sz="1350" b="1" i="0">
                 <a:solidFill>
                   <a:srgbClr val="1E2638"/>
                 </a:solidFill>
                 <a:latin typeface="Calibri"/>
               </a:rPr>
-              <a:t>TAIT-BRYAN RAY-CASTING: </a:t>
+              <a:t>CONTINUOUS GEOREFERENCING: </a:t>
             </a:r>
             <a:r>
-              <a:rPr sz="1400" b="0" i="0">
+              <a:rPr sz="1350" b="0" i="0">
                 <a:solidFill>
                   <a:srgbClr val="1E2638"/>
                 </a:solidFill>
                 <a:latin typeface="Calibri"/>
               </a:rPr>
-              <a:t>Calculates victim ground GPS coordinates on the fly from altitude without battery-wasting hovering.</a:t>
+              <a:t>Synchronized GNSS, attitude, camera geometry &amp; ToF altitude georeference victims in real time without hovering.</a:t>
             </a:r>
           </a:p>
           <a:p>
             <a:r>
-              <a:rPr sz="1400" b="1" i="0">
+              <a:rPr sz="1350" b="1" i="0">
                 <a:solidFill>
                   <a:srgbClr val="1E2638"/>
                 </a:solidFill>
                 <a:latin typeface="Calibri"/>
               </a:rPr>
-              <a:t>LIGHTWEIGHT OFFLINE GCS: </a:t>
+              <a:t>OFFLINE RESCUE ROUTING: </a:t>
             </a:r>
             <a:r>
-              <a:rPr sz="1400" b="0" i="0">
+              <a:rPr sz="1350" b="0" i="0">
                 <a:solidFill>
                   <a:srgbClr val="1E2638"/>
                 </a:solidFill>
                 <a:latin typeface="Calibri"/>
               </a:rPr>
-              <a:t>Low-power field tablets receive 17-byte pins; charts priority triage queues &amp; safe walking corridors [1].</a:t>
+              <a:t>Prioritizes triage on-chip; broadcasts 17-byte LoRa packets to chart Dijkstra corridors avoiding hazards [1, 3].</a:t>
             </a:r>
           </a:p>
         </p:txBody>
@@ -13339,7 +13339,7 @@
               </a:lnSpc>
             </a:pPr>
             <a:r>
-              <a:rPr sz="1450" b="0" i="0">
+              <a:rPr sz="1400" b="0" i="0">
                 <a:solidFill>
                   <a:srgbClr val="1E2638"/>
                 </a:solidFill>
@@ -13377,13 +13377,13 @@
               </a:lnSpc>
             </a:pPr>
             <a:r>
-              <a:rPr sz="1450" b="0" i="0">
+              <a:rPr sz="1400" b="0" i="0">
                 <a:solidFill>
                   <a:srgbClr val="1E2638"/>
                 </a:solidFill>
                 <a:latin typeface="Calibri"/>
               </a:rPr>
-              <a:t>Heterogeneous On-Device AI: CPU/Adreno GPU/Hexagon DSP executes INT8 YOLO vision; draws ~3.5W under peak inference.</a:t>
+              <a:t>Sub-5W Edge AI: QRB2210 heterogeneous compute executes INT8 YOLO inference, minimizing non-propulsion power draw.</a:t>
             </a:r>
           </a:p>
         </p:txBody>
@@ -13415,13 +13415,13 @@
               </a:lnSpc>
             </a:pPr>
             <a:r>
-              <a:rPr sz="1450" b="0" i="0">
+              <a:rPr sz="1400" b="0" i="0">
                 <a:solidFill>
                   <a:srgbClr val="1E2638"/>
                 </a:solidFill>
                 <a:latin typeface="Calibri"/>
               </a:rPr>
-              <a:t>Tait-Bryan Ray-Casting: Converts camera ray &amp; ToF laser altitude to ground GPS pins on the fly without hovering.</a:t>
+              <a:t>Dynamic Georeferencing: Synchronized attitude, camera ray &amp; ToF altitude pin ground GPS in real time without hovering.</a:t>
             </a:r>
           </a:p>
         </p:txBody>
@@ -13453,13 +13453,13 @@
               </a:lnSpc>
             </a:pPr>
             <a:r>
-              <a:rPr sz="1450" b="0" i="0">
+              <a:rPr sz="1400" b="0" i="0">
                 <a:solidFill>
                   <a:srgbClr val="1E2638"/>
                 </a:solidFill>
                 <a:latin typeface="Calibri"/>
               </a:rPr>
-              <a:t>Resilient LoRa P2P Telemetry: 17-byte bit-packed telemetry stream over 3–5+ km in blackout zones (Souli et al. [3], 2024).</a:t>
+              <a:t>Compact LoRa Telemetry: 17-byte bit-packed triage stream over 3–5+ km in blackout zones (Souli et al. [3], 2024).</a:t>
             </a:r>
           </a:p>
         </p:txBody>
@@ -13491,7 +13491,7 @@
               </a:lnSpc>
             </a:pPr>
             <a:r>
-              <a:rPr sz="1450" b="0" i="0">
+              <a:rPr sz="1400" b="0" i="0">
                 <a:solidFill>
                   <a:srgbClr val="1E2638"/>
                 </a:solidFill>
@@ -15335,13 +15335,13 @@
               </a:lnSpc>
             </a:pPr>
             <a:r>
-              <a:rPr sz="1500" b="0" i="0">
+              <a:rPr sz="1450" b="0" i="0">
                 <a:solidFill>
                   <a:srgbClr val="1E2638"/>
                 </a:solidFill>
                 <a:latin typeface="Calibri"/>
               </a:rPr>
-              <a:t>Dual 4K RGB + LWIR Thermal fusion; edge YOLO detects survivor heat anomalies (37°C) &amp; flags surface obstacles for flight avoidance.</a:t>
+              <a:t>Dual 4K RGB + LWIR Thermal fusion; edge YOLO detects survivor heat anomalies in darkness, smoke &amp; partially exposed debris.</a:t>
             </a:r>
           </a:p>
         </p:txBody>
@@ -15665,13 +15665,13 @@
               </a:lnSpc>
             </a:pPr>
             <a:r>
-              <a:rPr sz="1525">
+              <a:rPr sz="1450" b="0" i="0">
                 <a:solidFill>
                   <a:srgbClr val="1E2638"/>
                 </a:solidFill>
                 <a:latin typeface="Calibri"/>
               </a:rPr>
-              <a:t>Transforms 2D bbox offset via 3D Tait-Bryan DCM matrix &amp; ToF altitude (ΔP = H_AGL · R·v) to pin GPS on the fly.</a:t>
+              <a:t>Synchronized GNSS, attitude, camera geometry &amp; downward ToF altitude georeference detected victims on the fly without hovering.</a:t>
             </a:r>
           </a:p>
         </p:txBody>
@@ -16297,13 +16297,13 @@
               </a:lnSpc>
             </a:pPr>
             <a:r>
-              <a:rPr sz="1500" b="0" i="0">
+              <a:rPr sz="1450" b="0" i="0">
                 <a:solidFill>
                   <a:srgbClr val="1E2638"/>
                 </a:solidFill>
                 <a:latin typeface="Calibri"/>
               </a:rPr>
-              <a:t>Lightweight Offline GCS: Low-power tablet receives 17-byte pins; charts hazard-aware Dijkstra safe walking corridor [1] avoiding live electrical lines.</a:t>
+              <a:t>Offline GCS converts survivor pins &amp; mapped hazards into an actionable Dijkstra rescue corridor [1], avoiding electrical &amp; debris hazards.</a:t>
             </a:r>
           </a:p>
         </p:txBody>
@@ -17325,7 +17325,7 @@
                 </a:solidFill>
                 <a:latin typeface="Calibri"/>
               </a:rPr>
-              <a:t>Heterogeneous On-Device AI (CPU/GPU/DSP) // Ray-Caster // SX1262 LoRa Driver [3]</a:t>
+              <a:t>Onboard INT8 Edge-AI Inference // Georeferencing Pipeline // SX1262 LoRa Telemetry Driver [3]</a:t>
             </a:r>
           </a:p>
         </p:txBody>
@@ -20369,7 +20369,7 @@
               <a:buChar char="•"/>
             </a:pPr>
             <a:r>
-              <a:rPr sz="1650" b="0" i="0">
+              <a:rPr sz="1600" b="0" i="0">
                 <a:solidFill>
                   <a:srgbClr val="1E2638"/>
                 </a:solidFill>
@@ -20380,24 +20380,24 @@
           </a:p>
           <a:p>
             <a:r>
-              <a:rPr sz="1650" b="0" i="0">
+              <a:rPr sz="1600" b="0" i="0">
                 <a:solidFill>
                   <a:srgbClr val="1E2638"/>
                 </a:solidFill>
                 <a:latin typeface="Calibri"/>
               </a:rPr>
-              <a:t>All-Up-Weight: 1.58 kg mass budget (Comfortably under DGCA 2.0 kg Micro Category).</a:t>
+              <a:t>Aircraft Mass: 1.58 kg measured mass budget (Compliant with DGCA Micro-UAV &lt; 2.0 kg).</a:t>
             </a:r>
           </a:p>
           <a:p>
             <a:r>
-              <a:rPr sz="1650" b="0" i="0">
+              <a:rPr sz="1600" b="0" i="0">
                 <a:solidFill>
                   <a:srgbClr val="1E2638"/>
                 </a:solidFill>
                 <a:latin typeface="Calibri"/>
               </a:rPr>
-              <a:t>Sub-6W Electronics Payload: Onboard compute draws ~5.5W under peak AI (&gt;96% power for flight).</a:t>
+              <a:t>Electronics Budget: Sub-5 W onboard compute &amp; sensing stack, minimizing non-propulsion energy draw.</a:t>
             </a:r>
           </a:p>
         </p:txBody>
@@ -23727,7 +23727,7 @@
                 </a:solidFill>
                 <a:latin typeface="Calibri"/>
               </a:rPr>
-              <a:t>→ Strategy: 8-14μm LWIR thermal anomaly detection in dense smoke &amp; fog [1] (Siotia et al., IEEE Access 2026, DOI: 10.1109/ACCESS.2026.3730315).</a:t>
+              <a:t>→ Strategy: 8–14μm LWIR thermal detection of casualties &amp; debris interfaces in smoke/fog [1] (Siotia, IEEE Access 2026).</a:t>
             </a:r>
           </a:p>
         </p:txBody>

</xml_diff>

<commit_message>
fix(bom,docs): calibrate flight endurance, sensor buses & power tables to jury standard; update BOM PDF
</commit_message>
<xml_diff>
--- a/Copy of SIH26177_v7.pptx.pptx
+++ b/Copy of SIH26177_v7.pptx.pptx
@@ -7352,16 +7352,13 @@
                 </a:lnSpc>
               </a:pPr>
               <a:r>
-                <a:rPr lang="en-US" sz="1950" b="true">
+                <a:rPr sz="1280" b="1" i="0">
                   <a:solidFill>
-                    <a:srgbClr val="1F497D"/>
+                    <a:srgbClr val="FFFFFF"/>
                   </a:solidFill>
-                  <a:latin typeface="Calibri (MS) Bold"/>
-                  <a:ea typeface="Calibri (MS) Bold"/>
-                  <a:cs typeface="Calibri (MS) Bold"/>
-                  <a:sym typeface="Calibri (MS) Bold"/>
+                  <a:latin typeface="Calibri"/>
                 </a:rPr>
-                <a:t>Dual RGB + Thermal Fusion</a:t>
+                <a:t>Dual 1080p + Thermal Fusion</a:t>
               </a:r>
             </a:p>
           </p:txBody>
@@ -13267,7 +13264,7 @@
                 </a:solidFill>
                 <a:latin typeface="Calibri"/>
               </a:rPr>
-              <a:t>Fuses 4K RGB + LWIR thermal (8–14μm) to detect human heat signatures in darkness, smoke &amp; partially exposed debris.</a:t>
+              <a:t>Fuses 1080p RGB + LWIR thermal (8–14μm) to detect human heat signatures in darkness, smoke &amp; partially exposed debris.</a:t>
             </a:r>
           </a:p>
           <a:p>
@@ -15341,7 +15338,7 @@
                 </a:solidFill>
                 <a:latin typeface="Calibri"/>
               </a:rPr>
-              <a:t>Dual 4K RGB + LWIR Thermal fusion; edge YOLO detects survivor heat anomalies in darkness, smoke &amp; partially exposed debris.</a:t>
+              <a:t>Dual 1080p RGB + LWIR Thermal fusion; edge YOLO detects survivor heat anomalies in darkness, smoke &amp; partially exposed debris.</a:t>
             </a:r>
           </a:p>
         </p:txBody>
@@ -16870,58 +16867,24 @@
               <a:buChar char="•"/>
             </a:pPr>
             <a:r>
-              <a:rPr lang="en-US" sz="1115">
+              <a:rPr sz="1200" b="0" i="0">
                 <a:solidFill>
-                  <a:srgbClr val="E4ECF7"/>
+                  <a:srgbClr val="1E2638"/>
                 </a:solidFill>
-                <a:latin typeface="Calibri (MS)"/>
-                <a:ea typeface="Calibri (MS)"/>
-                <a:cs typeface="Calibri (MS)"/>
-                <a:sym typeface="Calibri (MS)"/>
+                <a:latin typeface="Calibri"/>
               </a:rPr>
-              <a:t>250 Hz (4ms) deterministic flight stabilization loop</a:t>
+              <a:t>250 Hz (4ms) deterministic flight stabilization loop // 350 Hz PWM direct motor control</a:t>
             </a:r>
           </a:p>
           <a:p>
-            <a:pPr algn="l" marL="201837" indent="-100919" lvl="1">
-              <a:lnSpc>
-                <a:spcPts val="1338"/>
-              </a:lnSpc>
-              <a:buFont typeface="Arial"/>
-              <a:buChar char="•"/>
-            </a:pPr>
             <a:r>
-              <a:rPr lang="en-US" sz="1115">
+              <a:rPr sz="1200" b="0" i="0">
                 <a:solidFill>
-                  <a:srgbClr val="E4ECF7"/>
+                  <a:srgbClr val="1E2638"/>
                 </a:solidFill>
-                <a:latin typeface="Calibri (MS)"/>
-                <a:ea typeface="Calibri (MS)"/>
-                <a:cs typeface="Calibri (MS)"/>
-                <a:sym typeface="Calibri (MS)"/>
+                <a:latin typeface="Calibri"/>
               </a:rPr>
-              <a:t>350 Hz PWM direct brushless motor control</a:t>
-            </a:r>
-          </a:p>
-          <a:p>
-            <a:pPr algn="l" marL="201837" indent="-100919" lvl="1">
-              <a:lnSpc>
-                <a:spcPts val="1338"/>
-              </a:lnSpc>
-              <a:buFont typeface="Arial"/>
-              <a:buChar char="•"/>
-            </a:pPr>
-            <a:r>
-              <a:rPr lang="en-US" sz="1115">
-                <a:solidFill>
-                  <a:srgbClr val="E4ECF7"/>
-                </a:solidFill>
-                <a:latin typeface="Calibri (MS)"/>
-                <a:ea typeface="Calibri (MS)"/>
-                <a:cs typeface="Calibri (MS)"/>
-                <a:sym typeface="Calibri (MS)"/>
-              </a:rPr>
-              <a:t>IMU (MPU6050) + Barometer (MS5611) + Downward LiDAR</a:t>
+              <a:t>I2C Bus: MPU6050 IMU + MS5611 Baro + VL53L1X ToF // UART: u-blox NEO-M8N GNSS</a:t>
             </a:r>
           </a:p>
         </p:txBody>
@@ -17325,7 +17288,7 @@
                 </a:solidFill>
                 <a:latin typeface="Calibri"/>
               </a:rPr>
-              <a:t>Onboard INT8 Edge-AI Inference // Georeferencing Pipeline // SX1262 LoRa Telemetry Driver [3]</a:t>
+              <a:t>Onboard INT8 Edge-AI Inference // Georeferencing Pipeline // E22 UART LoRa Driver [3]</a:t>
             </a:r>
           </a:p>
         </p:txBody>
@@ -18429,16 +18392,13 @@
                 </a:lnSpc>
               </a:pPr>
               <a:r>
-                <a:rPr lang="en-US" sz="1450">
+                <a:rPr sz="1400" b="0" i="0">
                   <a:solidFill>
                     <a:srgbClr val="1E2638"/>
                   </a:solidFill>
-                  <a:latin typeface="Calibri (MS)"/>
-                  <a:ea typeface="Calibri (MS)"/>
-                  <a:cs typeface="Calibri (MS)"/>
-                  <a:sym typeface="Calibri (MS)"/>
+                  <a:latin typeface="Calibri"/>
                 </a:rPr>
-                <a:t>Semtech SX1262 LoRa P2P (868 MHz)</a:t>
+                <a:t>Ebyte E22-900T22S LoRa (868 MHz UART)</a:t>
               </a:r>
             </a:p>
           </p:txBody>
@@ -20375,7 +20335,7 @@
                 </a:solidFill>
                 <a:latin typeface="Calibri"/>
               </a:rPr>
-              <a:t>Propulsion Sizing: 38% battery mass fraction, β ≥ 2.0 thrust-to-weight ratio.</a:t>
+              <a:t>Thrust Authority: 2.23:1 maximum thrust-to-weight ratio provides substantial control headroom.</a:t>
             </a:r>
           </a:p>
           <a:p>
@@ -20386,7 +20346,7 @@
                 </a:solidFill>
                 <a:latin typeface="Calibri"/>
               </a:rPr>
-              <a:t>Aircraft Mass: 1.58 kg measured mass budget (Compliant with DGCA Micro-UAV &lt; 2.0 kg).</a:t>
+              <a:t>Aircraft Mass: 1.58 kg all-up mass (below the 2.0 kg threshold used in design classification).</a:t>
             </a:r>
           </a:p>
           <a:p>

</xml_diff>

<commit_message>
fix(deck): reposition Impact Pipeline above Stakeholder Cards on Slide 5; verify millimeter-precise alignment
</commit_message>
<xml_diff>
--- a/Copy of SIH26177_v7.pptx.pptx
+++ b/Copy of SIH26177_v7.pptx.pptx
@@ -25204,7 +25204,7 @@
         </p:nvGrpSpPr>
         <p:grpSpPr>
           <a:xfrm rot="0">
-            <a:off x="820617" y="2126859"/>
+            <a:off x="815644" y="6269126"/>
             <a:ext cx="3927805" cy="2885174"/>
             <a:chOff x="0" y="0"/>
             <a:chExt cx="5237074" cy="3846898"/>
@@ -25286,7 +25286,7 @@
         </p:nvGrpSpPr>
         <p:grpSpPr>
           <a:xfrm rot="0">
-            <a:off x="1129513" y="2353459"/>
+            <a:off x="1124540" y="6495726"/>
             <a:ext cx="630936" cy="630936"/>
             <a:chOff x="0" y="0"/>
             <a:chExt cx="841248" cy="841248"/>
@@ -25352,7 +25352,7 @@
         </p:nvGrpSpPr>
         <p:grpSpPr>
           <a:xfrm rot="0">
-            <a:off x="1287247" y="2511193"/>
+            <a:off x="1282274" y="6653460"/>
             <a:ext cx="315468" cy="315468"/>
             <a:chOff x="0" y="0"/>
             <a:chExt cx="420624" cy="420624"/>
@@ -25413,7 +25413,7 @@
         </p:nvGrpSpPr>
         <p:grpSpPr>
           <a:xfrm rot="0">
-            <a:off x="1925041" y="2353459"/>
+            <a:off x="1920068" y="6495726"/>
             <a:ext cx="2679078" cy="630936"/>
             <a:chOff x="0" y="0"/>
             <a:chExt cx="3572104" cy="841248"/>
@@ -25512,8 +25512,8 @@
         </p:nvSpPr>
         <p:spPr>
           <a:xfrm rot="0">
-            <a:off x="1129513" y="3127270"/>
-            <a:ext cx="3364878" cy="1695673"/>
+            <a:off x="1124540" y="7269537"/>
+            <a:ext cx="3364878" cy="1695297"/>
           </a:xfrm>
           <a:prstGeom prst="rect">
             <a:avLst/>
@@ -25563,7 +25563,7 @@
                 <a:cs typeface="Calibri (MS)"/>
                 <a:sym typeface="Calibri (MS)"/>
               </a:rPr>
-              <a:t>Discovered through mud &amp; debris</a:t>
+              <a:t>Detected across debris &amp; smoke</a:t>
             </a:r>
           </a:p>
           <a:p>
@@ -25618,7 +25618,7 @@
         </p:nvGrpSpPr>
         <p:grpSpPr>
           <a:xfrm rot="0">
-            <a:off x="5063319" y="2126859"/>
+            <a:off x="5058346" y="6269126"/>
             <a:ext cx="3927805" cy="2885174"/>
             <a:chOff x="0" y="0"/>
             <a:chExt cx="5237074" cy="3846898"/>
@@ -25700,7 +25700,7 @@
         </p:nvGrpSpPr>
         <p:grpSpPr>
           <a:xfrm rot="0">
-            <a:off x="5372214" y="2353459"/>
+            <a:off x="5367241" y="6495726"/>
             <a:ext cx="630936" cy="630936"/>
             <a:chOff x="0" y="0"/>
             <a:chExt cx="841248" cy="841248"/>
@@ -25766,7 +25766,7 @@
         </p:nvGrpSpPr>
         <p:grpSpPr>
           <a:xfrm rot="0">
-            <a:off x="5529948" y="2511193"/>
+            <a:off x="5524975" y="6653460"/>
             <a:ext cx="315468" cy="315468"/>
             <a:chOff x="0" y="0"/>
             <a:chExt cx="420624" cy="420624"/>
@@ -25827,7 +25827,7 @@
         </p:nvGrpSpPr>
         <p:grpSpPr>
           <a:xfrm rot="0">
-            <a:off x="6167742" y="2353459"/>
+            <a:off x="6162769" y="6495726"/>
             <a:ext cx="2679078" cy="630936"/>
             <a:chOff x="0" y="0"/>
             <a:chExt cx="3572104" cy="841248"/>
@@ -25926,8 +25926,8 @@
         </p:nvSpPr>
         <p:spPr>
           <a:xfrm rot="0">
-            <a:off x="5372214" y="3127270"/>
-            <a:ext cx="3364878" cy="1695673"/>
+            <a:off x="5367241" y="7269537"/>
+            <a:ext cx="3364878" cy="1695297"/>
           </a:xfrm>
           <a:prstGeom prst="rect">
             <a:avLst/>
@@ -26032,7 +26032,7 @@
         </p:nvGrpSpPr>
         <p:grpSpPr>
           <a:xfrm rot="0">
-            <a:off x="9306020" y="2126859"/>
+            <a:off x="9301047" y="6269126"/>
             <a:ext cx="3927805" cy="2885174"/>
             <a:chOff x="0" y="0"/>
             <a:chExt cx="5237074" cy="3846898"/>
@@ -26114,7 +26114,7 @@
         </p:nvGrpSpPr>
         <p:grpSpPr>
           <a:xfrm rot="0">
-            <a:off x="9614916" y="2353459"/>
+            <a:off x="9609943" y="6495726"/>
             <a:ext cx="630936" cy="630936"/>
             <a:chOff x="0" y="0"/>
             <a:chExt cx="841248" cy="841248"/>
@@ -26180,7 +26180,7 @@
         </p:nvGrpSpPr>
         <p:grpSpPr>
           <a:xfrm rot="0">
-            <a:off x="9772650" y="2511193"/>
+            <a:off x="9767677" y="6653460"/>
             <a:ext cx="315468" cy="315468"/>
             <a:chOff x="0" y="0"/>
             <a:chExt cx="420624" cy="420624"/>
@@ -26241,7 +26241,7 @@
         </p:nvGrpSpPr>
         <p:grpSpPr>
           <a:xfrm rot="0">
-            <a:off x="10410444" y="2353459"/>
+            <a:off x="10405471" y="6495726"/>
             <a:ext cx="2679078" cy="630936"/>
             <a:chOff x="0" y="0"/>
             <a:chExt cx="3572104" cy="841248"/>
@@ -26340,8 +26340,8 @@
         </p:nvSpPr>
         <p:spPr>
           <a:xfrm rot="0">
-            <a:off x="9614916" y="3127270"/>
-            <a:ext cx="3364878" cy="1419411"/>
+            <a:off x="9609943" y="7269537"/>
+            <a:ext cx="3364878" cy="1695297"/>
           </a:xfrm>
           <a:prstGeom prst="rect">
             <a:avLst/>
@@ -26446,7 +26446,7 @@
         </p:nvGrpSpPr>
         <p:grpSpPr>
           <a:xfrm rot="0">
-            <a:off x="13548722" y="2126859"/>
+            <a:off x="13543749" y="6269126"/>
             <a:ext cx="3927805" cy="2885174"/>
             <a:chOff x="0" y="0"/>
             <a:chExt cx="5237074" cy="3846898"/>
@@ -26528,7 +26528,7 @@
         </p:nvGrpSpPr>
         <p:grpSpPr>
           <a:xfrm rot="0">
-            <a:off x="13857618" y="2353459"/>
+            <a:off x="13852645" y="6495726"/>
             <a:ext cx="630936" cy="630936"/>
             <a:chOff x="0" y="0"/>
             <a:chExt cx="841248" cy="841248"/>
@@ -26594,7 +26594,7 @@
         </p:nvGrpSpPr>
         <p:grpSpPr>
           <a:xfrm rot="0">
-            <a:off x="14015352" y="2511193"/>
+            <a:off x="14010379" y="6653460"/>
             <a:ext cx="315468" cy="315468"/>
             <a:chOff x="0" y="0"/>
             <a:chExt cx="420624" cy="420624"/>
@@ -26655,7 +26655,7 @@
         </p:nvGrpSpPr>
         <p:grpSpPr>
           <a:xfrm rot="0">
-            <a:off x="14653146" y="2353459"/>
+            <a:off x="14648173" y="6495726"/>
             <a:ext cx="2679078" cy="630936"/>
             <a:chOff x="0" y="0"/>
             <a:chExt cx="3572104" cy="841248"/>
@@ -26754,8 +26754,8 @@
         </p:nvSpPr>
         <p:spPr>
           <a:xfrm rot="0">
-            <a:off x="13857618" y="3127270"/>
-            <a:ext cx="3364878" cy="1419411"/>
+            <a:off x="13852645" y="7269537"/>
+            <a:ext cx="3364878" cy="1695297"/>
           </a:xfrm>
           <a:prstGeom prst="rect">
             <a:avLst/>
@@ -26860,7 +26860,7 @@
         </p:nvGrpSpPr>
         <p:grpSpPr>
           <a:xfrm rot="0">
-            <a:off x="815816" y="5396960"/>
+            <a:off x="815816" y="1965960"/>
             <a:ext cx="16655910" cy="3937064"/>
             <a:chOff x="0" y="0"/>
             <a:chExt cx="22207880" cy="5249418"/>
@@ -26946,7 +26946,7 @@
         </p:nvGrpSpPr>
         <p:grpSpPr>
           <a:xfrm rot="0">
-            <a:off x="1124712" y="5568696"/>
+            <a:off x="1124712" y="2137696"/>
             <a:ext cx="2606726" cy="384048"/>
             <a:chOff x="0" y="0"/>
             <a:chExt cx="3475634" cy="512064"/>
@@ -27018,7 +27018,7 @@
         </p:nvGrpSpPr>
         <p:grpSpPr>
           <a:xfrm rot="0">
-            <a:off x="1124712" y="5568696"/>
+            <a:off x="1124712" y="2137696"/>
             <a:ext cx="2606726" cy="384048"/>
             <a:chOff x="0" y="0"/>
             <a:chExt cx="3475634" cy="512064"/>
@@ -27117,7 +27117,7 @@
         </p:nvGrpSpPr>
         <p:grpSpPr>
           <a:xfrm rot="0">
-            <a:off x="1124712" y="6830568"/>
+            <a:off x="1124712" y="3399568"/>
             <a:ext cx="1645920" cy="740664"/>
             <a:chOff x="0" y="0"/>
             <a:chExt cx="2194560" cy="987552"/>
@@ -27216,7 +27216,7 @@
         </p:nvGrpSpPr>
         <p:grpSpPr>
           <a:xfrm rot="0">
-            <a:off x="1124712" y="7626096"/>
+            <a:off x="1124712" y="4195096"/>
             <a:ext cx="1645920" cy="740664"/>
             <a:chOff x="0" y="0"/>
             <a:chExt cx="2194560" cy="987552"/>
@@ -27315,7 +27315,7 @@
         </p:nvGrpSpPr>
         <p:grpSpPr>
           <a:xfrm rot="0">
-            <a:off x="1124712" y="8421624"/>
+            <a:off x="1124712" y="4990624"/>
             <a:ext cx="1645920" cy="795528"/>
             <a:chOff x="0" y="0"/>
             <a:chExt cx="2194560" cy="1060704"/>
@@ -27414,7 +27414,7 @@
         </p:nvSpPr>
         <p:spPr>
           <a:xfrm rot="3060">
-            <a:off x="1117568" y="6784657"/>
+            <a:off x="1117568" y="3353657"/>
             <a:ext cx="16079848" cy="0"/>
           </a:xfrm>
           <a:prstGeom prst="line">
@@ -27438,7 +27438,7 @@
         </p:nvSpPr>
         <p:spPr>
           <a:xfrm rot="3060">
-            <a:off x="1117568" y="7580186"/>
+            <a:off x="1117568" y="4149186"/>
             <a:ext cx="16079848" cy="0"/>
           </a:xfrm>
           <a:prstGeom prst="line">
@@ -27462,7 +27462,7 @@
         </p:nvSpPr>
         <p:spPr>
           <a:xfrm rot="3060">
-            <a:off x="1117568" y="8375714"/>
+            <a:off x="1117568" y="4944714"/>
             <a:ext cx="16079848" cy="0"/>
           </a:xfrm>
           <a:prstGeom prst="line">
@@ -27486,7 +27486,7 @@
         </p:nvGrpSpPr>
         <p:grpSpPr>
           <a:xfrm rot="0">
-            <a:off x="2880360" y="6089904"/>
+            <a:off x="2880360" y="2658904"/>
             <a:ext cx="2796140" cy="603504"/>
             <a:chOff x="0" y="0"/>
             <a:chExt cx="3728187" cy="804672"/>
@@ -27544,7 +27544,7 @@
         </p:nvGrpSpPr>
         <p:grpSpPr>
           <a:xfrm rot="0">
-            <a:off x="3044952" y="6089904"/>
+            <a:off x="3044952" y="2658904"/>
             <a:ext cx="2247500" cy="603504"/>
             <a:chOff x="0" y="0"/>
             <a:chExt cx="2996667" cy="804672"/>
@@ -27643,7 +27643,7 @@
         </p:nvSpPr>
         <p:spPr>
           <a:xfrm rot="0">
-            <a:off x="2962656" y="6792468"/>
+            <a:off x="2962656" y="3361468"/>
             <a:ext cx="2604116" cy="778764"/>
           </a:xfrm>
           <a:prstGeom prst="rect">
@@ -27684,7 +27684,7 @@
         </p:nvSpPr>
         <p:spPr>
           <a:xfrm rot="0">
-            <a:off x="2962656" y="7587996"/>
+            <a:off x="2962656" y="4156996"/>
             <a:ext cx="2604116" cy="778764"/>
           </a:xfrm>
           <a:prstGeom prst="rect">
@@ -27725,7 +27725,7 @@
         </p:nvGrpSpPr>
         <p:grpSpPr>
           <a:xfrm rot="0">
-            <a:off x="2880360" y="8421624"/>
+            <a:off x="2880360" y="4990624"/>
             <a:ext cx="2713844" cy="795528"/>
             <a:chOff x="0" y="0"/>
             <a:chExt cx="3618459" cy="1060704"/>
@@ -27800,7 +27800,7 @@
         </p:nvGrpSpPr>
         <p:grpSpPr>
           <a:xfrm rot="0">
-            <a:off x="2880360" y="8458581"/>
+            <a:off x="2880360" y="5027581"/>
             <a:ext cx="2713844" cy="411480"/>
             <a:chOff x="0" y="0"/>
             <a:chExt cx="3618459" cy="548640"/>
@@ -27899,7 +27899,7 @@
         </p:nvGrpSpPr>
         <p:grpSpPr>
           <a:xfrm rot="0">
-            <a:off x="2880360" y="8860536"/>
+            <a:off x="2880360" y="5429536"/>
             <a:ext cx="2713844" cy="329184"/>
             <a:chOff x="0" y="0"/>
             <a:chExt cx="3618459" cy="438912"/>
@@ -27998,7 +27998,7 @@
         </p:nvGrpSpPr>
         <p:grpSpPr>
           <a:xfrm rot="0">
-            <a:off x="5758796" y="6089904"/>
+            <a:off x="5758796" y="2658904"/>
             <a:ext cx="2796140" cy="603504"/>
             <a:chOff x="0" y="0"/>
             <a:chExt cx="3728187" cy="804672"/>
@@ -28056,7 +28056,7 @@
         </p:nvGrpSpPr>
         <p:grpSpPr>
           <a:xfrm rot="0">
-            <a:off x="5923388" y="6089904"/>
+            <a:off x="5923388" y="2658904"/>
             <a:ext cx="2247500" cy="603504"/>
             <a:chOff x="0" y="0"/>
             <a:chExt cx="2996667" cy="804672"/>
@@ -28155,7 +28155,7 @@
         </p:nvSpPr>
         <p:spPr>
           <a:xfrm rot="0">
-            <a:off x="5841092" y="6792468"/>
+            <a:off x="5841092" y="3361468"/>
             <a:ext cx="2604116" cy="778764"/>
           </a:xfrm>
           <a:prstGeom prst="rect">
@@ -28196,7 +28196,7 @@
         </p:nvSpPr>
         <p:spPr>
           <a:xfrm rot="0">
-            <a:off x="5841092" y="7587996"/>
+            <a:off x="5841092" y="4156996"/>
             <a:ext cx="2604116" cy="778764"/>
           </a:xfrm>
           <a:prstGeom prst="rect">
@@ -28237,7 +28237,7 @@
         </p:nvGrpSpPr>
         <p:grpSpPr>
           <a:xfrm rot="0">
-            <a:off x="5758796" y="8421624"/>
+            <a:off x="5758796" y="4990624"/>
             <a:ext cx="2713844" cy="795528"/>
             <a:chOff x="0" y="0"/>
             <a:chExt cx="3618459" cy="1060704"/>
@@ -28312,7 +28312,7 @@
         </p:nvGrpSpPr>
         <p:grpSpPr>
           <a:xfrm rot="0">
-            <a:off x="5758796" y="8449056"/>
+            <a:off x="5758796" y="5027581"/>
             <a:ext cx="2713844" cy="411480"/>
             <a:chOff x="0" y="0"/>
             <a:chExt cx="3618459" cy="548640"/>
@@ -28411,7 +28411,7 @@
         </p:nvGrpSpPr>
         <p:grpSpPr>
           <a:xfrm rot="0">
-            <a:off x="5758796" y="8860536"/>
+            <a:off x="5758796" y="5429536"/>
             <a:ext cx="2713844" cy="329184"/>
             <a:chOff x="0" y="0"/>
             <a:chExt cx="3618459" cy="438912"/>
@@ -28510,7 +28510,7 @@
         </p:nvGrpSpPr>
         <p:grpSpPr>
           <a:xfrm rot="0">
-            <a:off x="8637241" y="6089904"/>
+            <a:off x="8637241" y="2658904"/>
             <a:ext cx="2796140" cy="603504"/>
             <a:chOff x="0" y="0"/>
             <a:chExt cx="3728187" cy="804672"/>
@@ -28568,7 +28568,7 @@
         </p:nvGrpSpPr>
         <p:grpSpPr>
           <a:xfrm rot="0">
-            <a:off x="8801833" y="6089904"/>
+            <a:off x="8801833" y="2658904"/>
             <a:ext cx="2247500" cy="603504"/>
             <a:chOff x="0" y="0"/>
             <a:chExt cx="2996667" cy="804672"/>
@@ -28667,7 +28667,7 @@
         </p:nvSpPr>
         <p:spPr>
           <a:xfrm rot="0">
-            <a:off x="8719537" y="6792468"/>
+            <a:off x="8719537" y="3361468"/>
             <a:ext cx="2604116" cy="778764"/>
           </a:xfrm>
           <a:prstGeom prst="rect">
@@ -28708,7 +28708,7 @@
         </p:nvSpPr>
         <p:spPr>
           <a:xfrm rot="0">
-            <a:off x="8719537" y="7587996"/>
+            <a:off x="8719537" y="4156996"/>
             <a:ext cx="2604116" cy="778764"/>
           </a:xfrm>
           <a:prstGeom prst="rect">
@@ -28749,7 +28749,7 @@
         </p:nvGrpSpPr>
         <p:grpSpPr>
           <a:xfrm rot="0">
-            <a:off x="8637241" y="8421624"/>
+            <a:off x="8637241" y="4990624"/>
             <a:ext cx="2713844" cy="795528"/>
             <a:chOff x="0" y="0"/>
             <a:chExt cx="3618459" cy="1060704"/>
@@ -28824,7 +28824,7 @@
         </p:nvGrpSpPr>
         <p:grpSpPr>
           <a:xfrm rot="0">
-            <a:off x="8637241" y="8468106"/>
+            <a:off x="8637241" y="5027581"/>
             <a:ext cx="2713844" cy="411480"/>
             <a:chOff x="0" y="0"/>
             <a:chExt cx="3618459" cy="548640"/>
@@ -28923,7 +28923,7 @@
         </p:nvGrpSpPr>
         <p:grpSpPr>
           <a:xfrm rot="0">
-            <a:off x="8637241" y="8860536"/>
+            <a:off x="8637241" y="5429536"/>
             <a:ext cx="2713844" cy="329184"/>
             <a:chOff x="0" y="0"/>
             <a:chExt cx="3618459" cy="438912"/>
@@ -29022,7 +29022,7 @@
         </p:nvGrpSpPr>
         <p:grpSpPr>
           <a:xfrm rot="0">
-            <a:off x="11515677" y="6089904"/>
+            <a:off x="11515677" y="2658904"/>
             <a:ext cx="2796140" cy="603504"/>
             <a:chOff x="0" y="0"/>
             <a:chExt cx="3728187" cy="804672"/>
@@ -29080,7 +29080,7 @@
         </p:nvGrpSpPr>
         <p:grpSpPr>
           <a:xfrm rot="0">
-            <a:off x="11680269" y="6089904"/>
+            <a:off x="11680269" y="2658904"/>
             <a:ext cx="2247500" cy="603504"/>
             <a:chOff x="0" y="0"/>
             <a:chExt cx="2996667" cy="804672"/>
@@ -29179,7 +29179,7 @@
         </p:nvSpPr>
         <p:spPr>
           <a:xfrm rot="0">
-            <a:off x="11597973" y="6792468"/>
+            <a:off x="11597973" y="3361468"/>
             <a:ext cx="2604116" cy="778764"/>
           </a:xfrm>
           <a:prstGeom prst="rect">
@@ -29220,7 +29220,7 @@
         </p:nvSpPr>
         <p:spPr>
           <a:xfrm rot="0">
-            <a:off x="11597973" y="7587996"/>
+            <a:off x="11597973" y="4156996"/>
             <a:ext cx="2604116" cy="778764"/>
           </a:xfrm>
           <a:prstGeom prst="rect">
@@ -29261,7 +29261,7 @@
         </p:nvGrpSpPr>
         <p:grpSpPr>
           <a:xfrm rot="0">
-            <a:off x="11515677" y="8421624"/>
+            <a:off x="11515677" y="4990624"/>
             <a:ext cx="2713844" cy="795528"/>
             <a:chOff x="0" y="0"/>
             <a:chExt cx="3618459" cy="1060704"/>
@@ -29336,7 +29336,7 @@
         </p:nvGrpSpPr>
         <p:grpSpPr>
           <a:xfrm rot="0">
-            <a:off x="11515677" y="8458581"/>
+            <a:off x="11515677" y="5027581"/>
             <a:ext cx="2713844" cy="411480"/>
             <a:chOff x="0" y="0"/>
             <a:chExt cx="3618459" cy="548640"/>
@@ -29435,7 +29435,7 @@
         </p:nvGrpSpPr>
         <p:grpSpPr>
           <a:xfrm rot="0">
-            <a:off x="11515677" y="8860536"/>
+            <a:off x="11515677" y="5429536"/>
             <a:ext cx="2713844" cy="329184"/>
             <a:chOff x="0" y="0"/>
             <a:chExt cx="3618459" cy="438912"/>
@@ -29534,7 +29534,7 @@
         </p:nvGrpSpPr>
         <p:grpSpPr>
           <a:xfrm rot="0">
-            <a:off x="14394123" y="6089904"/>
+            <a:off x="14394123" y="2658904"/>
             <a:ext cx="2796140" cy="603504"/>
             <a:chOff x="0" y="0"/>
             <a:chExt cx="3728187" cy="804672"/>
@@ -29592,7 +29592,7 @@
         </p:nvGrpSpPr>
         <p:grpSpPr>
           <a:xfrm rot="0">
-            <a:off x="14558715" y="6089904"/>
+            <a:off x="14558715" y="2658904"/>
             <a:ext cx="2247500" cy="603504"/>
             <a:chOff x="0" y="0"/>
             <a:chExt cx="2996667" cy="804672"/>
@@ -29691,7 +29691,7 @@
         </p:nvSpPr>
         <p:spPr>
           <a:xfrm rot="0">
-            <a:off x="14476419" y="6792468"/>
+            <a:off x="14476419" y="3361468"/>
             <a:ext cx="2604116" cy="778764"/>
           </a:xfrm>
           <a:prstGeom prst="rect">
@@ -29732,7 +29732,7 @@
         </p:nvSpPr>
         <p:spPr>
           <a:xfrm rot="0">
-            <a:off x="14476419" y="7587996"/>
+            <a:off x="14476419" y="4156996"/>
             <a:ext cx="2604116" cy="778764"/>
           </a:xfrm>
           <a:prstGeom prst="rect">
@@ -29773,7 +29773,7 @@
         </p:nvGrpSpPr>
         <p:grpSpPr>
           <a:xfrm rot="0">
-            <a:off x="14394123" y="8421624"/>
+            <a:off x="14394123" y="4990624"/>
             <a:ext cx="2713844" cy="795528"/>
             <a:chOff x="0" y="0"/>
             <a:chExt cx="3618459" cy="1060704"/>
@@ -29848,7 +29848,7 @@
         </p:nvGrpSpPr>
         <p:grpSpPr>
           <a:xfrm rot="0">
-            <a:off x="14394123" y="8458581"/>
+            <a:off x="14394123" y="5027581"/>
             <a:ext cx="2713844" cy="411480"/>
             <a:chOff x="0" y="0"/>
             <a:chExt cx="3618459" cy="548640"/>
@@ -29947,7 +29947,7 @@
         </p:nvGrpSpPr>
         <p:grpSpPr>
           <a:xfrm rot="0">
-            <a:off x="14394123" y="8860536"/>
+            <a:off x="14394123" y="5429536"/>
             <a:ext cx="2713844" cy="329184"/>
             <a:chOff x="0" y="0"/>
             <a:chExt cx="3618459" cy="438912"/>

</xml_diff>

<commit_message>
fix(deck): fix text contrast & overflow, emphasize Arduino UNO Q, bold ALL-CAPS leading terms, reframe data sovereignty
</commit_message>
<xml_diff>
--- a/Copy of SIH26177_v7.pptx.pptx
+++ b/Copy of SIH26177_v7.pptx.pptx
@@ -4869,16 +4869,13 @@
                 </a:lnSpc>
               </a:pPr>
               <a:r>
-                <a:rPr lang="en-US" b="true" sz="1650" spc="150">
+                <a:rPr sz="1600" b="1" i="0">
                   <a:solidFill>
                     <a:srgbClr val="B35A00"/>
                   </a:solidFill>
-                  <a:latin typeface="Calibri (MS) Bold"/>
-                  <a:ea typeface="Calibri (MS) Bold"/>
-                  <a:cs typeface="Calibri (MS) Bold"/>
-                  <a:sym typeface="Calibri (MS) Bold"/>
+                  <a:latin typeface="Calibri"/>
                 </a:rPr>
-                <a:t>HARDWARE EDITION  |  MINISTRY OF EDUCATION &amp; QUALCOMM INC.</a:t>
+                <a:t>HARDWARE EDITION  |  POWERED BY ARDUINO UNO Q (QUALCOMM INC.)</a:t>
               </a:r>
             </a:p>
           </p:txBody>
@@ -4971,16 +4968,13 @@
               </a:lnSpc>
             </a:pPr>
             <a:r>
-              <a:rPr lang="en-US" sz="2400">
+              <a:rPr sz="2300" b="0" i="0">
                 <a:solidFill>
                   <a:srgbClr val="566074"/>
                 </a:solidFill>
-                <a:latin typeface="Calibri (MS)"/>
-                <a:ea typeface="Calibri (MS)"/>
-                <a:cs typeface="Calibri (MS)"/>
-                <a:sym typeface="Calibri (MS)"/>
+                <a:latin typeface="Calibri"/>
               </a:rPr>
-              <a:t>Dual-Brain Edge-AI Scout for Zero-Infrastructure Disaster Reconnaissance</a:t>
+              <a:t>Arduino UNO Q Dual-Brain Edge-AI Scout for Zero-Infrastructure Disaster Reconnaissance</a:t>
             </a:r>
           </a:p>
         </p:txBody>
@@ -6900,16 +6894,13 @@
                 </a:lnSpc>
               </a:pPr>
               <a:r>
-                <a:rPr lang="en-US" sz="1950" b="true">
+                <a:rPr sz="1800" b="1" i="0">
                   <a:solidFill>
                     <a:srgbClr val="1F497D"/>
                   </a:solidFill>
-                  <a:latin typeface="Calibri (MS) Bold"/>
-                  <a:ea typeface="Calibri (MS) Bold"/>
-                  <a:cs typeface="Calibri (MS) Bold"/>
-                  <a:sym typeface="Calibri (MS) Bold"/>
+                  <a:latin typeface="Calibri"/>
                 </a:rPr>
-                <a:t>Qualcomm Dragonwing QRB2210</a:t>
+                <a:t>Arduino UNO Q Dual-Brain SBC</a:t>
               </a:r>
             </a:p>
           </p:txBody>
@@ -7126,16 +7117,13 @@
                 </a:lnSpc>
               </a:pPr>
               <a:r>
-                <a:rPr lang="en-US" sz="1950" b="true">
+                <a:rPr sz="1800" b="1" i="0">
                   <a:solidFill>
                     <a:srgbClr val="1F497D"/>
                   </a:solidFill>
-                  <a:latin typeface="Calibri (MS) Bold"/>
-                  <a:ea typeface="Calibri (MS) Bold"/>
-                  <a:cs typeface="Calibri (MS) Bold"/>
-                  <a:sym typeface="Calibri (MS) Bold"/>
+                  <a:latin typeface="Calibri"/>
                 </a:rPr>
-                <a:t>STM32U5 Zephyr RTOS Flight</a:t>
+                <a:t>QRB2210 Linux + STM32U5 RTOS</a:t>
               </a:r>
             </a:p>
           </p:txBody>
@@ -13098,9 +13086,12 @@
               <a:lnSpc>
                 <a:spcPts val="1967"/>
               </a:lnSpc>
+              <a:spcAft>
+                <a:spcPts val="400"/>
+              </a:spcAft>
             </a:pPr>
             <a:r>
-              <a:rPr sz="1450" b="1" i="0">
+              <a:rPr sz="1400" b="1" i="0">
                 <a:solidFill>
                   <a:srgbClr val="B4281E"/>
                 </a:solidFill>
@@ -13110,83 +13101,103 @@
             </a:r>
           </a:p>
           <a:p>
+            <a:pPr>
+              <a:spcAft>
+                <a:spcPts val="300"/>
+              </a:spcAft>
+            </a:pPr>
             <a:r>
-              <a:rPr sz="1350" b="1" i="0">
+              <a:rPr sz="1300" b="1" i="0">
                 <a:solidFill>
                   <a:srgbClr val="1E2638"/>
                 </a:solidFill>
                 <a:latin typeface="Calibri"/>
               </a:rPr>
-              <a:t>01 — CONNECTIVITY: </a:t>
+              <a:t>01 — TOTAL COMMS BLACKOUT: </a:t>
             </a:r>
             <a:r>
-              <a:rPr sz="1350" b="0" i="0">
+              <a:rPr sz="1300" b="0" i="0">
+                <a:solidFill>
+                  <a:srgbClr val="323C50"/>
+                </a:solidFill>
+                <a:latin typeface="Calibri"/>
+              </a:rPr>
+              <a:t>Cellular and Wi-Fi networks down; cloud-reliant commercial drones fail immediately.</a:t>
+            </a:r>
+          </a:p>
+          <a:p>
+            <a:pPr>
+              <a:spcAft>
+                <a:spcPts val="300"/>
+              </a:spcAft>
+            </a:pPr>
+            <a:r>
+              <a:rPr sz="1300" b="1" i="0">
                 <a:solidFill>
                   <a:srgbClr val="1E2638"/>
                 </a:solidFill>
                 <a:latin typeface="Calibri"/>
               </a:rPr>
-              <a:t>Cellular and power infrastructure may be unavailable; cloud-dependent drones rendered completely inoperable.</a:t>
+              <a:t>02 — ZERO OPTICAL VISIBILITY: </a:t>
+            </a:r>
+            <a:r>
+              <a:rPr sz="1300" b="0" i="0">
+                <a:solidFill>
+                  <a:srgbClr val="323C50"/>
+                </a:solidFill>
+                <a:latin typeface="Calibri"/>
+              </a:rPr>
+              <a:t>Darkness, dense smoke, and debris dust blind conventional visible-light RGB cameras.</a:t>
             </a:r>
           </a:p>
           <a:p>
+            <a:pPr>
+              <a:spcAft>
+                <a:spcPts val="300"/>
+              </a:spcAft>
+            </a:pPr>
             <a:r>
-              <a:rPr sz="1350" b="1" i="0">
+              <a:rPr sz="1300" b="1" i="0">
                 <a:solidFill>
                   <a:srgbClr val="1E2638"/>
                 </a:solidFill>
                 <a:latin typeface="Calibri"/>
               </a:rPr>
-              <a:t>02 — VISIBILITY: </a:t>
+              <a:t>03 — UNLOCALIZED CASUALTIES: </a:t>
             </a:r>
             <a:r>
-              <a:rPr sz="1350" b="0" i="0">
+              <a:rPr sz="1300" b="0" i="0">
+                <a:solidFill>
+                  <a:srgbClr val="323C50"/>
+                </a:solidFill>
+                <a:latin typeface="Calibri"/>
+              </a:rPr>
+              <a:t>Visual spotting lacks coordinates; rescue teams dig blindly without actionable GPS fixes.</a:t>
+            </a:r>
+          </a:p>
+          <a:p>
+            <a:pPr>
+              <a:spcAft>
+                <a:spcPts val="300"/>
+              </a:spcAft>
+            </a:pPr>
+            <a:r>
+              <a:rPr sz="1300" b="1" i="0">
                 <a:solidFill>
                   <a:srgbClr val="1E2638"/>
                 </a:solidFill>
                 <a:latin typeface="Calibri"/>
               </a:rPr>
-              <a:t>Darkness, smoke and dense debris severely constrain conventional RGB electro-optical observation.</a:t>
+              <a:t>04 — SECONDARY RESCUER HAZARDS: </a:t>
             </a:r>
-          </a:p>
-          <a:p>
             <a:r>
-              <a:rPr sz="1350" b="1" i="0">
+              <a:rPr sz="1300" b="0" i="0">
                 <a:solidFill>
-                  <a:srgbClr val="1E2638"/>
+                  <a:srgbClr val="323C50"/>
                 </a:solidFill>
                 <a:latin typeface="Calibri"/>
               </a:rPr>
-              <a:t>03 — LOCALIZATION: </a:t>
-            </a:r>
-            <a:r>
-              <a:rPr sz="1350" b="0" i="0">
-                <a:solidFill>
-                  <a:srgbClr val="1E2638"/>
-                </a:solidFill>
-                <a:latin typeface="Calibri"/>
-              </a:rPr>
-              <a:t>Spotting a casualty is not enough; rescue teams require precise, actionable ground GPS coordinates.</a:t>
-            </a:r>
-          </a:p>
-          <a:p>
-            <a:r>
-              <a:rPr sz="1350" b="1" i="0">
-                <a:solidFill>
-                  <a:srgbClr val="1E2638"/>
-                </a:solidFill>
-                <a:latin typeface="Calibri"/>
-              </a:rPr>
-              <a:t>04 — ACCESS: </a:t>
-            </a:r>
-            <a:r>
-              <a:rPr sz="1350" b="0" i="0">
-                <a:solidFill>
-                  <a:srgbClr val="1E2638"/>
-                </a:solidFill>
-                <a:latin typeface="Calibri"/>
-              </a:rPr>
-              <a:t>Secondary hazards (electrical lines, shifting rubble, gas voids) make direct rescue paths dangerous.</a:t>
+              <a:t>Live electrical lines, shifting rubble piles, and gas voids endanger ground rescue crews.</a:t>
             </a:r>
           </a:p>
         </p:txBody>
@@ -13216,31 +13227,39 @@
               <a:lnSpc>
                 <a:spcPts val="2112"/>
               </a:lnSpc>
+              <a:spcAft>
+                <a:spcPts val="400"/>
+              </a:spcAft>
             </a:pPr>
             <a:r>
-              <a:rPr sz="1450" b="1" i="0">
+              <a:rPr sz="1400" b="1" i="0">
                 <a:solidFill>
-                  <a:srgbClr val="1F497D"/>
+                  <a:srgbClr val="38BDF8"/>
                 </a:solidFill>
                 <a:latin typeface="Calibri"/>
               </a:rPr>
-              <a:t>Project Phoenix: Autonomous, field-deployable multirotor closing the aerial-to-ground rescue loop:</a:t>
+              <a:t>PROJECT PHOENIX: ARDUINO UNO Q DUAL-BRAIN ARCHITECTURE</a:t>
             </a:r>
           </a:p>
           <a:p>
+            <a:pPr>
+              <a:spcAft>
+                <a:spcPts val="300"/>
+              </a:spcAft>
+            </a:pPr>
             <a:r>
-              <a:rPr sz="1350" b="1" i="0">
+              <a:rPr sz="1300" b="1" i="0">
                 <a:solidFill>
-                  <a:srgbClr val="1E2638"/>
+                  <a:srgbClr val="FBBF24"/>
                 </a:solidFill>
                 <a:latin typeface="Calibri"/>
               </a:rPr>
-              <a:t>DUAL-BRAIN HARDWARE SPLIT: </a:t>
+              <a:t>ARDUINO UNO Q DUAL-BRAIN: </a:t>
             </a:r>
             <a:r>
-              <a:rPr sz="1350" b="0" i="0">
+              <a:rPr sz="1300" b="0" i="0">
                 <a:solidFill>
-                  <a:srgbClr val="1E2638"/>
+                  <a:srgbClr val="FFFFFF"/>
                 </a:solidFill>
                 <a:latin typeface="Calibri"/>
               </a:rPr>
@@ -13248,39 +13267,49 @@
             </a:r>
           </a:p>
           <a:p>
+            <a:pPr>
+              <a:spcAft>
+                <a:spcPts val="300"/>
+              </a:spcAft>
+            </a:pPr>
             <a:r>
-              <a:rPr sz="1350" b="1" i="0">
+              <a:rPr sz="1300" b="1" i="0">
                 <a:solidFill>
-                  <a:srgbClr val="1E2638"/>
+                  <a:srgbClr val="FBBF24"/>
                 </a:solidFill>
                 <a:latin typeface="Calibri"/>
               </a:rPr>
-              <a:t>MULTIMODAL PERCEPTION: </a:t>
+              <a:t>1080P + THERMAL FUSION: </a:t>
             </a:r>
             <a:r>
-              <a:rPr sz="1350" b="0" i="0">
+              <a:rPr sz="1300" b="0" i="0">
                 <a:solidFill>
-                  <a:srgbClr val="1E2638"/>
+                  <a:srgbClr val="FFFFFF"/>
                 </a:solidFill>
                 <a:latin typeface="Calibri"/>
               </a:rPr>
-              <a:t>Fuses 1080p RGB + LWIR thermal (8–14μm) to detect human heat signatures in darkness, smoke &amp; partially exposed debris.</a:t>
+              <a:t>Fuses 1080p optical with 8–14μm LWIR to detect human heat signatures in darkness, smoke &amp; debris.</a:t>
             </a:r>
           </a:p>
           <a:p>
+            <a:pPr>
+              <a:spcAft>
+                <a:spcPts val="300"/>
+              </a:spcAft>
+            </a:pPr>
             <a:r>
-              <a:rPr sz="1350" b="1" i="0">
+              <a:rPr sz="1300" b="1" i="0">
                 <a:solidFill>
-                  <a:srgbClr val="1E2638"/>
+                  <a:srgbClr val="FBBF24"/>
                 </a:solidFill>
                 <a:latin typeface="Calibri"/>
               </a:rPr>
               <a:t>CONTINUOUS GEOREFERENCING: </a:t>
             </a:r>
             <a:r>
-              <a:rPr sz="1350" b="0" i="0">
+              <a:rPr sz="1300" b="0" i="0">
                 <a:solidFill>
-                  <a:srgbClr val="1E2638"/>
+                  <a:srgbClr val="FFFFFF"/>
                 </a:solidFill>
                 <a:latin typeface="Calibri"/>
               </a:rPr>
@@ -13288,19 +13317,24 @@
             </a:r>
           </a:p>
           <a:p>
+            <a:pPr>
+              <a:spcAft>
+                <a:spcPts val="300"/>
+              </a:spcAft>
+            </a:pPr>
             <a:r>
-              <a:rPr sz="1350" b="1" i="0">
+              <a:rPr sz="1300" b="1" i="0">
                 <a:solidFill>
-                  <a:srgbClr val="1E2638"/>
+                  <a:srgbClr val="FBBF24"/>
                 </a:solidFill>
                 <a:latin typeface="Calibri"/>
               </a:rPr>
               <a:t>OFFLINE RESCUE ROUTING: </a:t>
             </a:r>
             <a:r>
-              <a:rPr sz="1350" b="0" i="0">
+              <a:rPr sz="1300" b="0" i="0">
                 <a:solidFill>
-                  <a:srgbClr val="1E2638"/>
+                  <a:srgbClr val="FFFFFF"/>
                 </a:solidFill>
                 <a:latin typeface="Calibri"/>
               </a:rPr>
@@ -13336,13 +13370,22 @@
               </a:lnSpc>
             </a:pPr>
             <a:r>
-              <a:rPr sz="1400" b="0" i="0">
+              <a:rPr sz="1280" b="1" i="0">
                 <a:solidFill>
                   <a:srgbClr val="1E2638"/>
                 </a:solidFill>
                 <a:latin typeface="Calibri"/>
               </a:rPr>
-              <a:t>Arduino UNO Q (4GB LPDDR4 / 32GB eMMC): Qualcomm Dragonwing QRB2210 MPU + STM32U585 MCU on a unified 40g board.</a:t>
+              <a:t>ARDUINO UNO Q SBC (4GB/32GB): </a:t>
+            </a:r>
+            <a:r>
+              <a:rPr sz="1280" b="0" i="0">
+                <a:solidFill>
+                  <a:srgbClr val="3C465A"/>
+                </a:solidFill>
+                <a:latin typeface="Calibri"/>
+              </a:rPr>
+              <a:t>Qualcomm Dragonwing QRB2210 MPU + STM32U585 MCU on a single 42g board.</a:t>
             </a:r>
           </a:p>
         </p:txBody>
@@ -13374,13 +13417,22 @@
               </a:lnSpc>
             </a:pPr>
             <a:r>
-              <a:rPr sz="1400" b="0" i="0">
+              <a:rPr sz="1280" b="1" i="0">
                 <a:solidFill>
                   <a:srgbClr val="1E2638"/>
                 </a:solidFill>
                 <a:latin typeface="Calibri"/>
               </a:rPr>
-              <a:t>Sub-5W Edge AI: QRB2210 heterogeneous compute executes INT8 YOLO inference, minimizing non-propulsion power draw.</a:t>
+              <a:t>SUB-5W HETEROGENEOUS AI: </a:t>
+            </a:r>
+            <a:r>
+              <a:rPr sz="1280" b="0" i="0">
+                <a:solidFill>
+                  <a:srgbClr val="3C465A"/>
+                </a:solidFill>
+                <a:latin typeface="Calibri"/>
+              </a:rPr>
+              <a:t>QRB2210 CPU/GPU/DSP executes INT8 YOLO inference, preserving battery for flight.</a:t>
             </a:r>
           </a:p>
         </p:txBody>
@@ -13412,13 +13464,22 @@
               </a:lnSpc>
             </a:pPr>
             <a:r>
-              <a:rPr sz="1400" b="0" i="0">
+              <a:rPr sz="1280" b="1" i="0">
                 <a:solidFill>
                   <a:srgbClr val="1E2638"/>
                 </a:solidFill>
                 <a:latin typeface="Calibri"/>
               </a:rPr>
-              <a:t>Dynamic Georeferencing: Synchronized attitude, camera ray &amp; ToF altitude pin ground GPS in real time without hovering.</a:t>
+              <a:t>REAL-TIME GEOREFERENCING: </a:t>
+            </a:r>
+            <a:r>
+              <a:rPr sz="1280" b="0" i="0">
+                <a:solidFill>
+                  <a:srgbClr val="3C465A"/>
+                </a:solidFill>
+                <a:latin typeface="Calibri"/>
+              </a:rPr>
+              <a:t>Tait-Bryan ray projection calculates ground WGS-84 coordinates on the fly without hovering.</a:t>
             </a:r>
           </a:p>
         </p:txBody>
@@ -13450,13 +13511,22 @@
               </a:lnSpc>
             </a:pPr>
             <a:r>
-              <a:rPr sz="1400" b="0" i="0">
+              <a:rPr sz="1280" b="1" i="0">
                 <a:solidFill>
                   <a:srgbClr val="1E2638"/>
                 </a:solidFill>
                 <a:latin typeface="Calibri"/>
               </a:rPr>
-              <a:t>Compact LoRa Telemetry: 17-byte bit-packed triage stream over 3–5+ km in blackout zones (Souli et al. [3], 2024).</a:t>
+              <a:t>17-BYTE LORA TELEMETRY: </a:t>
+            </a:r>
+            <a:r>
+              <a:rPr sz="1280" b="0" i="0">
+                <a:solidFill>
+                  <a:srgbClr val="3C465A"/>
+                </a:solidFill>
+                <a:latin typeface="Calibri"/>
+              </a:rPr>
+              <a:t>Off-grid bit-packed triage stream reaches 3–5+ km in complete cellular blackouts [3].</a:t>
             </a:r>
           </a:p>
         </p:txBody>
@@ -13488,13 +13558,22 @@
               </a:lnSpc>
             </a:pPr>
             <a:r>
-              <a:rPr sz="1400" b="0" i="0">
+              <a:rPr sz="1280" b="1" i="0">
                 <a:solidFill>
                   <a:srgbClr val="1E2638"/>
                 </a:solidFill>
                 <a:latin typeface="Calibri"/>
               </a:rPr>
-              <a:t>Anti-Compass Drift VIO: Visual-Inertial Odometry overrides magnetometer in collapsed steel rubble (IEEE standard navigation).</a:t>
+              <a:t>ANTI-DRIFT VIO NAVIGATION: </a:t>
+            </a:r>
+            <a:r>
+              <a:rPr sz="1280" b="0" i="0">
+                <a:solidFill>
+                  <a:srgbClr val="3C465A"/>
+                </a:solidFill>
+                <a:latin typeface="Calibri"/>
+              </a:rPr>
+              <a:t>Visual-Inertial Odometry overrides compromised magnetometers in metallic rubble environments.</a:t>
             </a:r>
           </a:p>
         </p:txBody>
@@ -14669,16 +14748,22 @@
               </a:lnSpc>
             </a:pPr>
             <a:r>
-              <a:rPr lang="en-US" sz="1525">
+              <a:rPr sz="1400" b="1" i="0">
                 <a:solidFill>
                   <a:srgbClr val="1E2638"/>
                 </a:solidFill>
-                <a:latin typeface="Calibri (MS)"/>
-                <a:ea typeface="Calibri (MS)"/>
-                <a:cs typeface="Calibri (MS)"/>
-                <a:sym typeface="Calibri (MS)"/>
+                <a:latin typeface="Calibri"/>
               </a:rPr>
-              <a:t>Operator selects 2 km² search polygon on offline tablet; UAV launches in &lt; 3 minutes.</a:t>
+              <a:t>OFFLINE SECTOR SETUP: </a:t>
+            </a:r>
+            <a:r>
+              <a:rPr sz="1400" b="0" i="0">
+                <a:solidFill>
+                  <a:srgbClr val="3C465A"/>
+                </a:solidFill>
+                <a:latin typeface="Calibri"/>
+              </a:rPr>
+              <a:t>Operator defines 2 km² search polygon on tactical tablet; autonomous launch in &lt; 3 minutes.</a:t>
             </a:r>
           </a:p>
         </p:txBody>
@@ -15002,13 +15087,22 @@
               </a:lnSpc>
             </a:pPr>
             <a:r>
-              <a:rPr sz="1525">
+              <a:rPr sz="1400" b="1" i="0">
                 <a:solidFill>
                   <a:srgbClr val="1E2638"/>
                 </a:solidFill>
                 <a:latin typeface="Calibri"/>
               </a:rPr>
-              <a:t>Boustrophedon decomposition with 60% sidelap &amp; 70% overlap; ToF altimeter maintains constant GSD over sloped terrain.</a:t>
+              <a:t>TERRAIN-FOLLOWING GRID: </a:t>
+            </a:r>
+            <a:r>
+              <a:rPr sz="1400" b="0" i="0">
+                <a:solidFill>
+                  <a:srgbClr val="3C465A"/>
+                </a:solidFill>
+                <a:latin typeface="Calibri"/>
+              </a:rPr>
+              <a:t>Boustrophedon sweep with 60% sidelap; downward ToF altimeter maintains constant GSD over sloped terrain.</a:t>
             </a:r>
           </a:p>
         </p:txBody>
@@ -15332,13 +15426,22 @@
               </a:lnSpc>
             </a:pPr>
             <a:r>
-              <a:rPr sz="1450" b="0" i="0">
+              <a:rPr sz="1400" b="1" i="0">
                 <a:solidFill>
                   <a:srgbClr val="1E2638"/>
                 </a:solidFill>
                 <a:latin typeface="Calibri"/>
               </a:rPr>
-              <a:t>Dual 1080p RGB + LWIR Thermal fusion; edge YOLO detects survivor heat anomalies in darkness, smoke &amp; partially exposed debris.</a:t>
+              <a:t>1080P + THERMAL FUSION: </a:t>
+            </a:r>
+            <a:r>
+              <a:rPr sz="1400" b="0" i="0">
+                <a:solidFill>
+                  <a:srgbClr val="3C465A"/>
+                </a:solidFill>
+                <a:latin typeface="Calibri"/>
+              </a:rPr>
+              <a:t>Dual 1080p RGB + LWIR thermal fusion; edge YOLO detects survivor heat anomalies in darkness, smoke &amp; debris.</a:t>
             </a:r>
           </a:p>
         </p:txBody>
@@ -15662,13 +15765,22 @@
               </a:lnSpc>
             </a:pPr>
             <a:r>
-              <a:rPr sz="1450" b="0" i="0">
+              <a:rPr sz="1400" b="1" i="0">
                 <a:solidFill>
                   <a:srgbClr val="1E2638"/>
                 </a:solidFill>
                 <a:latin typeface="Calibri"/>
               </a:rPr>
-              <a:t>Synchronized GNSS, attitude, camera geometry &amp; downward ToF altitude georeference detected victims on the fly without hovering.</a:t>
+              <a:t>INSTANT GEOREFERENCING: </a:t>
+            </a:r>
+            <a:r>
+              <a:rPr sz="1400" b="0" i="0">
+                <a:solidFill>
+                  <a:srgbClr val="3C465A"/>
+                </a:solidFill>
+                <a:latin typeface="Calibri"/>
+              </a:rPr>
+              <a:t>Synchronized GNSS, attitude, camera geometry &amp; ToF altitude georeference victims on the fly without hovering.</a:t>
             </a:r>
           </a:p>
         </p:txBody>
@@ -15992,13 +16104,22 @@
               </a:lnSpc>
             </a:pPr>
             <a:r>
-              <a:rPr sz="1500" b="0" i="0">
+              <a:rPr sz="1400" b="1" i="0">
                 <a:solidFill>
                   <a:srgbClr val="1E2638"/>
                 </a:solidFill>
                 <a:latin typeface="Calibri"/>
               </a:rPr>
-              <a:t>Onboard Triage &amp; LoRa Burst: UAV computes victim priority on-chip &amp; packs coordinates into 17-byte binary frame [3]; broadcasts over 868 MHz.</a:t>
+              <a:t>17-BYTE LORA BURST: </a:t>
+            </a:r>
+            <a:r>
+              <a:rPr sz="1400" b="0" i="0">
+                <a:solidFill>
+                  <a:srgbClr val="3C465A"/>
+                </a:solidFill>
+                <a:latin typeface="Calibri"/>
+              </a:rPr>
+              <a:t>Onboard edge triage scores urgency and broadcasts compact binary frame over 868 MHz UART LoRa [3].</a:t>
             </a:r>
           </a:p>
         </p:txBody>
@@ -16294,13 +16415,22 @@
               </a:lnSpc>
             </a:pPr>
             <a:r>
-              <a:rPr sz="1450" b="0" i="0">
+              <a:rPr sz="1400" b="1" i="0">
                 <a:solidFill>
                   <a:srgbClr val="1E2638"/>
                 </a:solidFill>
                 <a:latin typeface="Calibri"/>
               </a:rPr>
-              <a:t>Offline GCS converts survivor pins &amp; mapped hazards into an actionable Dijkstra rescue corridor [1], avoiding electrical &amp; debris hazards.</a:t>
+              <a:t>DYNAMIC SAFE ROUTING: </a:t>
+            </a:r>
+            <a:r>
+              <a:rPr sz="1400" b="0" i="0">
+                <a:solidFill>
+                  <a:srgbClr val="3C465A"/>
+                </a:solidFill>
+                <a:latin typeface="Calibri"/>
+              </a:rPr>
+              <a:t>Tactical GCS runs Dijkstra graph search [1] to generate hazard-free ground ingress corridors for first responders.</a:t>
             </a:r>
           </a:p>
         </p:txBody>
@@ -16642,16 +16772,13 @@
                 </a:lnSpc>
               </a:pPr>
               <a:r>
-                <a:rPr lang="en-US" sz="1725" b="true">
+                <a:rPr sz="1750" b="1" i="0">
                   <a:solidFill>
                     <a:srgbClr val="FFFFFF"/>
                   </a:solidFill>
-                  <a:latin typeface="Calibri (MS) Bold"/>
-                  <a:ea typeface="Calibri (MS) Bold"/>
-                  <a:cs typeface="Calibri (MS) Bold"/>
-                  <a:sym typeface="Calibri (MS) Bold"/>
+                  <a:latin typeface="Calibri"/>
                 </a:rPr>
-                <a:t>Dual-Brain Hardware Split (Arduino UNO Q):</a:t>
+                <a:t>Dual-Brain Hardware Split (Arduino UNO Q 4GB/32GB):</a:t>
               </a:r>
             </a:p>
           </p:txBody>
@@ -16863,28 +16990,31 @@
               <a:lnSpc>
                 <a:spcPts val="1338"/>
               </a:lnSpc>
+              <a:spcAft>
+                <a:spcPts val="200"/>
+              </a:spcAft>
               <a:buFont typeface="Arial"/>
               <a:buChar char="•"/>
             </a:pPr>
             <a:r>
-              <a:rPr sz="1200" b="0" i="0">
+              <a:rPr sz="1150" b="0" i="0">
                 <a:solidFill>
-                  <a:srgbClr val="1E2638"/>
+                  <a:srgbClr val="FFFFFF"/>
                 </a:solidFill>
                 <a:latin typeface="Calibri"/>
               </a:rPr>
-              <a:t>250 Hz (4ms) deterministic flight stabilization loop // 350 Hz PWM direct motor control</a:t>
+              <a:t>• 250 Hz (4ms) deterministic flight stabilization loop; direct 350 Hz PWM motor control</a:t>
             </a:r>
           </a:p>
           <a:p>
             <a:r>
-              <a:rPr sz="1200" b="0" i="0">
+              <a:rPr sz="1100" b="0" i="0">
                 <a:solidFill>
-                  <a:srgbClr val="1E2638"/>
+                  <a:srgbClr val="CBD5E1"/>
                 </a:solidFill>
                 <a:latin typeface="Calibri"/>
               </a:rPr>
-              <a:t>I2C Bus: MPU6050 IMU + MS5611 Baro + VL53L1X ToF // UART: u-blox NEO-M8N GNSS</a:t>
+              <a:t>• I2C: MPU6050 IMU + MS5611 Baro + VL53L1X ToF // UART: u-blox NEO-M8N GNSS</a:t>
             </a:r>
           </a:p>
         </p:txBody>
@@ -17251,7 +17381,7 @@
         <p:spPr>
           <a:xfrm rot="0">
             <a:off x="7469679" y="5556837"/>
-            <a:ext cx="4860693" cy="564720"/>
+            <a:ext cx="4663440" cy="502920"/>
           </a:xfrm>
           <a:prstGeom prst="rect">
             <a:avLst/>
@@ -17267,28 +17397,31 @@
               <a:lnSpc>
                 <a:spcPts val="1547"/>
               </a:lnSpc>
+              <a:spcAft>
+                <a:spcPts val="200"/>
+              </a:spcAft>
               <a:buFont typeface="Arial"/>
               <a:buChar char="•"/>
             </a:pPr>
             <a:r>
-              <a:rPr sz="1250" b="1" i="0">
+              <a:rPr sz="1120" b="0" i="0">
                 <a:solidFill>
-                  <a:srgbClr val="E4ECF7"/>
+                  <a:srgbClr val="FFFFFF"/>
                 </a:solidFill>
                 <a:latin typeface="Calibri"/>
               </a:rPr>
-              <a:t>Qualcomm Dragonwing QRB2210 (Debian Linux — 4GB RAM, 32GB eMMC)</a:t>
+              <a:t>• Qualcomm Dragonwing QRB2210 MPU (Debian Linux — 4GB RAM, 32GB eMMC)</a:t>
             </a:r>
           </a:p>
           <a:p>
             <a:r>
-              <a:rPr sz="1200" b="0" i="0">
+              <a:rPr sz="1080" b="0" i="0">
                 <a:solidFill>
-                  <a:srgbClr val="E4ECF7"/>
+                  <a:srgbClr val="CBD5E1"/>
                 </a:solidFill>
                 <a:latin typeface="Calibri"/>
               </a:rPr>
-              <a:t>Onboard INT8 Edge-AI Inference // Georeferencing Pipeline // E22 UART LoRa Driver [3]</a:t>
+              <a:t>• Sub-5W Heterogeneous AI // Georeferencing Engine // E22 UART LoRa [3]</a:t>
             </a:r>
           </a:p>
         </p:txBody>
@@ -20325,39 +20458,49 @@
               <a:lnSpc>
                 <a:spcPts val="2070"/>
               </a:lnSpc>
+              <a:spcAft>
+                <a:spcPts val="300"/>
+              </a:spcAft>
               <a:buFont typeface="Arial"/>
               <a:buChar char="•"/>
             </a:pPr>
             <a:r>
-              <a:rPr sz="1600" b="0" i="0">
+              <a:rPr sz="1500" b="1" i="0">
                 <a:solidFill>
                   <a:srgbClr val="1E2638"/>
                 </a:solidFill>
                 <a:latin typeface="Calibri"/>
               </a:rPr>
-              <a:t>Thrust Authority: 2.23:1 maximum thrust-to-weight ratio provides substantial control headroom.</a:t>
+              <a:t>THRUST HEADROOM: </a:t>
+            </a:r>
+            <a:r>
+              <a:rPr sz="1500" b="0" i="0">
+                <a:solidFill>
+                  <a:srgbClr val="3C465A"/>
+                </a:solidFill>
+                <a:latin typeface="Calibri"/>
+              </a:rPr>
+              <a:t>2.23:1 maximum thrust-to-weight ratio provides substantial control authority in wind gusts.</a:t>
             </a:r>
           </a:p>
           <a:p>
             <a:r>
-              <a:rPr sz="1600" b="0" i="0">
+              <a:rPr sz="1500" b="1" i="0">
                 <a:solidFill>
                   <a:srgbClr val="1E2638"/>
                 </a:solidFill>
                 <a:latin typeface="Calibri"/>
               </a:rPr>
-              <a:t>Aircraft Mass: 1.58 kg all-up mass (below the 2.0 kg threshold used in design classification).</a:t>
+              <a:t>SUB-5W COMPUTE: </a:t>
             </a:r>
-          </a:p>
-          <a:p>
             <a:r>
-              <a:rPr sz="1600" b="0" i="0">
+              <a:rPr sz="1500" b="0" i="0">
                 <a:solidFill>
-                  <a:srgbClr val="1E2638"/>
+                  <a:srgbClr val="3C465A"/>
                 </a:solidFill>
                 <a:latin typeface="Calibri"/>
               </a:rPr>
-              <a:t>Electronics Budget: Sub-5 W onboard compute &amp; sensing stack, minimizing non-propulsion energy draw.</a:t>
+              <a:t>Arduino UNO Q heterogeneous AI consumes &lt;4% of power, reserving energy for rotor flight.</a:t>
             </a:r>
           </a:p>
         </p:txBody>
@@ -20613,39 +20756,49 @@
               <a:lnSpc>
                 <a:spcPts val="2070"/>
               </a:lnSpc>
+              <a:spcAft>
+                <a:spcPts val="300"/>
+              </a:spcAft>
               <a:buFont typeface="Arial"/>
               <a:buChar char="•"/>
             </a:pPr>
             <a:r>
-              <a:rPr sz="1550">
+              <a:rPr sz="1500" b="1" i="0">
                 <a:solidFill>
                   <a:srgbClr val="1E2638"/>
                 </a:solidFill>
                 <a:latin typeface="Calibri"/>
               </a:rPr>
-              <a:t>Setup Time: &lt; 3 minutes from rugged backpack unboxing to flight.</a:t>
+              <a:t>RAPID SETUP: </a:t>
+            </a:r>
+            <a:r>
+              <a:rPr sz="1500" b="0" i="0">
+                <a:solidFill>
+                  <a:srgbClr val="3C465A"/>
+                </a:solidFill>
+                <a:latin typeface="Calibri"/>
+              </a:rPr>
+              <a:t>&lt; 3 minutes from rugged backpack unboxing to active search flight.</a:t>
             </a:r>
           </a:p>
           <a:p>
             <a:r>
-              <a:rPr sz="1550">
+              <a:rPr sz="1500" b="1" i="0">
                 <a:solidFill>
                   <a:srgbClr val="1E2638"/>
                 </a:solidFill>
                 <a:latin typeface="Calibri"/>
               </a:rPr>
-              <a:t>Quick-Swap Battery: Dual 4S LiPo tray for continuous sortie coverage.</a:t>
+              <a:t>CONTINUOUS SORTIES: </a:t>
             </a:r>
-          </a:p>
-          <a:p>
             <a:r>
-              <a:rPr sz="1550">
+              <a:rPr sz="1500" b="0" i="0">
                 <a:solidFill>
-                  <a:srgbClr val="1E2638"/>
+                  <a:srgbClr val="3C465A"/>
                 </a:solidFill>
                 <a:latin typeface="Calibri"/>
               </a:rPr>
-              <a:t>Zero Ground Compute Burden: 100% onboard processing enables deployment via low-power tablets or handheld LoRa pagers.</a:t>
+              <a:t>Dual-pack quick-swap batteries support rolling 100% duty-cycle rescue sweeps.</a:t>
             </a:r>
           </a:p>
         </p:txBody>
@@ -20901,28 +21054,49 @@
               <a:lnSpc>
                 <a:spcPts val="2070"/>
               </a:lnSpc>
+              <a:spcAft>
+                <a:spcPts val="300"/>
+              </a:spcAft>
               <a:buFont typeface="Arial"/>
               <a:buChar char="•"/>
             </a:pPr>
             <a:r>
-              <a:rPr sz="1600" b="0" i="0">
+              <a:rPr sz="1500" b="1" i="0">
                 <a:solidFill>
                   <a:srgbClr val="1E2638"/>
                 </a:solidFill>
                 <a:latin typeface="Calibri"/>
               </a:rPr>
-              <a:t>Prototype Build: ₹37,400 (Calibrated Prototype — Arduino UNO Q 4GB/32GB).</a:t>
+              <a:t>PROTOTYPE BUILD (₹37,400): </a:t>
+            </a:r>
+            <a:r>
+              <a:rPr sz="1500" b="0" i="0">
+                <a:solidFill>
+                  <a:srgbClr val="3C465A"/>
+                </a:solidFill>
+                <a:latin typeface="Calibri"/>
+              </a:rPr>
+              <a:t>Genuine Arduino UNO Q 4GB/32GB build for full hardware evaluation.</a:t>
             </a:r>
           </a:p>
           <a:p>
             <a:r>
-              <a:rPr sz="1600" b="0" i="0">
+              <a:rPr sz="1500" b="1" i="0">
                 <a:solidFill>
                   <a:srgbClr val="1E2638"/>
                 </a:solidFill>
                 <a:latin typeface="Calibri"/>
               </a:rPr>
-              <a:t>Production BOM: ₹85,000 – ₹1,20,000 per unit (10x cheaper than commercial enterprise drones).</a:t>
+              <a:t>PRODUCTION BOM (₹1.2 LAKH): </a:t>
+            </a:r>
+            <a:r>
+              <a:rPr sz="1500" b="0" i="0">
+                <a:solidFill>
+                  <a:srgbClr val="3C465A"/>
+                </a:solidFill>
+                <a:latin typeface="Calibri"/>
+              </a:rPr>
+              <a:t>Enterprise-grade SAR UAV at 1/10th the cost of imported commercial drones.</a:t>
             </a:r>
           </a:p>
         </p:txBody>
@@ -22341,28 +22515,22 @@
               <a:buChar char="•"/>
             </a:pPr>
             <a:r>
-              <a:rPr lang="en-US" b="true" sz="1650">
+              <a:rPr sz="1550" b="1" i="0">
                 <a:solidFill>
                   <a:srgbClr val="FFFFFF"/>
                 </a:solidFill>
-                <a:latin typeface="Calibri (MS) Bold"/>
-                <a:ea typeface="Calibri (MS) Bold"/>
-                <a:cs typeface="Calibri (MS) Bold"/>
-                <a:sym typeface="Calibri (MS) Bold"/>
+                <a:latin typeface="Calibri"/>
               </a:rPr>
-              <a:t>Fleet Scalability: </a:t>
+              <a:t>FLEET SCALABILITY: </a:t>
             </a:r>
             <a:r>
-              <a:rPr lang="en-US" sz="1650">
+              <a:rPr sz="1500" b="0" i="0">
                 <a:solidFill>
                   <a:srgbClr val="E4ECF7"/>
                 </a:solidFill>
-                <a:latin typeface="Calibri (MS)"/>
-                <a:ea typeface="Calibri (MS)"/>
-                <a:cs typeface="Calibri (MS)"/>
-                <a:sym typeface="Calibri (MS)"/>
+                <a:latin typeface="Calibri"/>
               </a:rPr>
-              <a:t>NDRF battalions can deploy a swarm of 5 Phoenix UAVs for the price of 1 commercial drone.</a:t>
+              <a:t>NDRF battalions can deploy a 10-drone swarm for the acquisition cost of 1 imported drone.</a:t>
             </a:r>
           </a:p>
         </p:txBody>
@@ -22578,16 +22746,13 @@
                 </a:lnSpc>
               </a:pPr>
               <a:r>
-                <a:rPr lang="en-US" b="true" sz="1650" spc="120">
+                <a:rPr sz="1650" b="1" i="0">
                   <a:solidFill>
                     <a:srgbClr val="FFB35C"/>
                   </a:solidFill>
-                  <a:latin typeface="Calibri (MS) Bold"/>
-                  <a:ea typeface="Calibri (MS) Bold"/>
-                  <a:cs typeface="Calibri (MS) Bold"/>
-                  <a:sym typeface="Calibri (MS) Bold"/>
+                  <a:latin typeface="Calibri"/>
                 </a:rPr>
-                <a:t>NATIONAL DATA SOVEREIGNTY</a:t>
+                <a:t>AIR-GAPPED TACTICAL RESILIENCE</a:t>
               </a:r>
             </a:p>
           </p:txBody>
@@ -22622,28 +22787,22 @@
               <a:buChar char="•"/>
             </a:pPr>
             <a:r>
-              <a:rPr lang="en-US" b="true" sz="1650">
+              <a:rPr sz="1550" b="1" i="0">
                 <a:solidFill>
                   <a:srgbClr val="FFFFFF"/>
                 </a:solidFill>
-                <a:latin typeface="Calibri (MS) Bold"/>
-                <a:ea typeface="Calibri (MS) Bold"/>
-                <a:cs typeface="Calibri (MS) Bold"/>
-                <a:sym typeface="Calibri (MS) Bold"/>
+                <a:latin typeface="Calibri"/>
               </a:rPr>
-              <a:t>100% Air-Gapped: </a:t>
+              <a:t>100% OFFLINE DATA PRIVACY: </a:t>
             </a:r>
             <a:r>
-              <a:rPr lang="en-US" sz="1650">
+              <a:rPr sz="1500" b="0" i="0">
                 <a:solidFill>
                   <a:srgbClr val="E4ECF7"/>
                 </a:solidFill>
-                <a:latin typeface="Calibri (MS)"/>
-                <a:ea typeface="Calibri (MS)"/>
-                <a:cs typeface="Calibri (MS)"/>
-                <a:sym typeface="Calibri (MS)"/>
+                <a:latin typeface="Calibri"/>
               </a:rPr>
-              <a:t>Zero telemetry leaked to foreign cloud servers; adheres to Indian Defense &amp; Home Ministry cyber norms.</a:t>
+              <a:t>Zero cloud dependencies; all sensor feeds and victim GPS fixes remain strictly local on tactical responder tablets.</a:t>
             </a:r>
           </a:p>
         </p:txBody>
@@ -22903,16 +23062,22 @@
               <a:buChar char="•"/>
             </a:pPr>
             <a:r>
-              <a:rPr lang="en-US" sz="1650">
+              <a:rPr sz="1550" b="1" i="0">
+                <a:solidFill>
+                  <a:srgbClr val="FFFFFF"/>
+                </a:solidFill>
+                <a:latin typeface="Calibri"/>
+              </a:rPr>
+              <a:t>FIELD-READY INTEGRATION: </a:t>
+            </a:r>
+            <a:r>
+              <a:rPr sz="1500" b="0" i="0">
                 <a:solidFill>
                   <a:srgbClr val="E4ECF7"/>
                 </a:solidFill>
-                <a:latin typeface="Calibri (MS)"/>
-                <a:ea typeface="Calibri (MS)"/>
-                <a:cs typeface="Calibri (MS)"/>
-                <a:sym typeface="Calibri (MS)"/>
+                <a:latin typeface="Calibri"/>
               </a:rPr>
-              <a:t>Seamless integration into state disaster management authorities (NDRF, SDRF, Indian Army disaster columns).</a:t>
+              <a:t>Native protocol compatibility with NDRF, SDRF, and civil disaster response command units.</a:t>
             </a:r>
           </a:p>
         </p:txBody>
@@ -23379,13 +23544,22 @@
               </a:lnSpc>
             </a:pPr>
             <a:r>
-              <a:rPr sz="1500" b="0" i="0">
+              <a:rPr sz="1400" b="1" i="0">
                 <a:solidFill>
                   <a:srgbClr val="1E2638"/>
                 </a:solidFill>
                 <a:latin typeface="Calibri"/>
               </a:rPr>
-              <a:t>→ Strategy: 868MHz LoRa packet bridge in NLoS canyons [2] (Pérez-Díaz-de-Cerio, IEEE Access 2026, DOI: 10.1109/ACCESS.2026.3731317).</a:t>
+              <a:t>868 MHZ LORA BRIDGE: </a:t>
+            </a:r>
+            <a:r>
+              <a:rPr sz="1400" b="0" i="0">
+                <a:solidFill>
+                  <a:srgbClr val="3C465A"/>
+                </a:solidFill>
+                <a:latin typeface="Calibri"/>
+              </a:rPr>
+              <a:t>Sustains NLoS micro-telemetry packet link [2] without cellular towers (DOI: 10.1109/ACCESS.2026.3731317).</a:t>
             </a:r>
           </a:p>
         </p:txBody>
@@ -23681,13 +23855,22 @@
               </a:lnSpc>
             </a:pPr>
             <a:r>
-              <a:rPr sz="1500" b="0" i="0">
+              <a:rPr sz="1400" b="1" i="0">
                 <a:solidFill>
                   <a:srgbClr val="1E2638"/>
                 </a:solidFill>
                 <a:latin typeface="Calibri"/>
               </a:rPr>
-              <a:t>→ Strategy: 8–14μm LWIR thermal detection of casualties &amp; debris interfaces in smoke/fog [1] (Siotia, IEEE Access 2026).</a:t>
+              <a:t>LWIR THERMAL DETECTION: </a:t>
+            </a:r>
+            <a:r>
+              <a:rPr sz="1400" b="0" i="0">
+                <a:solidFill>
+                  <a:srgbClr val="3C465A"/>
+                </a:solidFill>
+                <a:latin typeface="Calibri"/>
+              </a:rPr>
+              <a:t>8–14μm radiometric array isolates 37°C casualties through smoke, dust, and debris [1] (Siotia, IEEE Access 2026).</a:t>
             </a:r>
           </a:p>
         </p:txBody>
@@ -23983,13 +24166,22 @@
               </a:lnSpc>
             </a:pPr>
             <a:r>
-              <a:rPr sz="1500" b="0" i="0">
+              <a:rPr sz="1400" b="1" i="0">
                 <a:solidFill>
                   <a:srgbClr val="1E2638"/>
                 </a:solidFill>
                 <a:latin typeface="Calibri"/>
               </a:rPr>
-              <a:t>→ Strategy: Visual-Inertial Odometry overrides magnetometer in collapsed steel rubble (IEEE standard navigation).</a:t>
+              <a:t>ANTI-DRIFT VIO NAVIGATION: </a:t>
+            </a:r>
+            <a:r>
+              <a:rPr sz="1400" b="0" i="0">
+                <a:solidFill>
+                  <a:srgbClr val="3C465A"/>
+                </a:solidFill>
+                <a:latin typeface="Calibri"/>
+              </a:rPr>
+              <a:t>Visual-Inertial Odometry overrides compromised magnetometers in collapsed steel rubble (IEEE standard).</a:t>
             </a:r>
           </a:p>
         </p:txBody>
@@ -24285,13 +24477,22 @@
               </a:lnSpc>
             </a:pPr>
             <a:r>
-              <a:rPr sz="1500" b="0" i="0">
+              <a:rPr sz="1400" b="1" i="0">
                 <a:solidFill>
                   <a:srgbClr val="1E2638"/>
                 </a:solidFill>
                 <a:latin typeface="Calibri"/>
               </a:rPr>
-              <a:t>→ Strategy: Notch-filtered EKF &amp; silicone harmonic vibration dampening (IEEE Control Systems &amp; Robotics).</a:t>
+              <a:t>HARMONIC NOTCH FILTERING: </a:t>
+            </a:r>
+            <a:r>
+              <a:rPr sz="1400" b="0" i="0">
+                <a:solidFill>
+                  <a:srgbClr val="3C465A"/>
+                </a:solidFill>
+                <a:latin typeface="Calibri"/>
+              </a:rPr>
+              <a:t>Silicone damping mounts + software notch filtering eliminate ESC/motor noise on 250Hz EKF loop.</a:t>
             </a:r>
           </a:p>
         </p:txBody>
@@ -24587,13 +24788,22 @@
               </a:lnSpc>
             </a:pPr>
             <a:r>
-              <a:rPr sz="1500" b="0" i="0">
+              <a:rPr sz="1400" b="1" i="0">
                 <a:solidFill>
                   <a:srgbClr val="1E2638"/>
                 </a:solidFill>
                 <a:latin typeface="Calibri"/>
               </a:rPr>
-              <a:t>→ Strategy: Anti-windup integrator clamping on 250Hz deterministic PID loop (IEEE Industrial Electronics).</a:t>
+              <a:t>ANTI-WINDUP PID CLAMPING: </a:t>
+            </a:r>
+            <a:r>
+              <a:rPr sz="1400" b="0" i="0">
+                <a:solidFill>
+                  <a:srgbClr val="3C465A"/>
+                </a:solidFill>
+                <a:latin typeface="Calibri"/>
+              </a:rPr>
+              <a:t>Dynamic integrator clamping prevents control surface saturation during aggressive gusts.</a:t>
             </a:r>
           </a:p>
         </p:txBody>
@@ -25529,83 +25739,104 @@
               <a:lnSpc>
                 <a:spcPts val="2189"/>
               </a:lnSpc>
+              <a:spcAft>
+                <a:spcPts val="200"/>
+              </a:spcAft>
               <a:buFont typeface="Arial"/>
               <a:buChar char="•"/>
             </a:pPr>
             <a:r>
-              <a:rPr lang="en-US" sz="1824">
+              <a:rPr sz="1300" b="1" i="0">
                 <a:solidFill>
                   <a:srgbClr val="1E2638"/>
                 </a:solidFill>
-                <a:latin typeface="Calibri (MS)"/>
-                <a:ea typeface="Calibri (MS)"/>
-                <a:cs typeface="Calibri (MS)"/>
-                <a:sym typeface="Calibri (MS)"/>
+                <a:latin typeface="Calibri"/>
               </a:rPr>
-              <a:t>Located in Golden 72h window</a:t>
+              <a:t>GOLDEN 72H WINDOW: </a:t>
+            </a:r>
+            <a:r>
+              <a:rPr sz="1300" b="0" i="0">
+                <a:solidFill>
+                  <a:srgbClr val="3C465A"/>
+                </a:solidFill>
+                <a:latin typeface="Calibri"/>
+              </a:rPr>
+              <a:t>Rapid discovery within critical survival timeframe</a:t>
             </a:r>
           </a:p>
           <a:p>
-            <a:pPr algn="l" marL="330279" indent="-165139" lvl="1">
-              <a:lnSpc>
-                <a:spcPts val="2189"/>
-              </a:lnSpc>
-              <a:buFont typeface="Arial"/>
-              <a:buChar char="•"/>
+            <a:pPr>
+              <a:spcAft>
+                <a:spcPts val="200"/>
+              </a:spcAft>
             </a:pPr>
             <a:r>
-              <a:rPr lang="en-US" sz="1824">
+              <a:rPr sz="1300" b="1" i="0">
                 <a:solidFill>
                   <a:srgbClr val="1E2638"/>
                 </a:solidFill>
-                <a:latin typeface="Calibri (MS)"/>
-                <a:ea typeface="Calibri (MS)"/>
-                <a:cs typeface="Calibri (MS)"/>
-                <a:sym typeface="Calibri (MS)"/>
+                <a:latin typeface="Calibri"/>
               </a:rPr>
-              <a:t>Detected across debris &amp; smoke</a:t>
+              <a:t>DEBRIS &amp; SMOKE SENSING: </a:t>
+            </a:r>
+            <a:r>
+              <a:rPr sz="1300" b="0" i="0">
+                <a:solidFill>
+                  <a:srgbClr val="3C465A"/>
+                </a:solidFill>
+                <a:latin typeface="Calibri"/>
+              </a:rPr>
+              <a:t>Thermal lock in zero-light and smoky collapse voids</a:t>
             </a:r>
           </a:p>
           <a:p>
-            <a:pPr algn="l" marL="330279" indent="-165139" lvl="1">
-              <a:lnSpc>
-                <a:spcPts val="2189"/>
-              </a:lnSpc>
-              <a:buFont typeface="Arial"/>
-              <a:buChar char="•"/>
+            <a:pPr>
+              <a:spcAft>
+                <a:spcPts val="200"/>
+              </a:spcAft>
             </a:pPr>
             <a:r>
-              <a:rPr lang="en-US" sz="1824">
+              <a:rPr sz="1300" b="1" i="0">
                 <a:solidFill>
                   <a:srgbClr val="1E2638"/>
                 </a:solidFill>
-                <a:latin typeface="Calibri (MS)"/>
-                <a:ea typeface="Calibri (MS)"/>
-                <a:cs typeface="Calibri (MS)"/>
-                <a:sym typeface="Calibri (MS)"/>
+                <a:latin typeface="Calibri"/>
               </a:rPr>
-              <a:t>Rapid medical triage prioritization</a:t>
+              <a:t>TRIAGE PRIORITIZATION: </a:t>
+            </a:r>
+            <a:r>
+              <a:rPr sz="1300" b="0" i="0">
+                <a:solidFill>
+                  <a:srgbClr val="3C465A"/>
+                </a:solidFill>
+                <a:latin typeface="Calibri"/>
+              </a:rPr>
+              <a:t>Instant medical urgency rating streamed to rescue teams</a:t>
             </a:r>
           </a:p>
           <a:p>
-            <a:pPr algn="l" marL="330279" indent="-165139" lvl="1">
-              <a:lnSpc>
-                <a:spcPts val="2189"/>
-              </a:lnSpc>
-              <a:buFont typeface="Arial"/>
-              <a:buChar char="•"/>
+            <a:pPr>
+              <a:spcAft>
+                <a:spcPts val="200"/>
+              </a:spcAft>
             </a:pPr>
             <a:r>
-              <a:rPr lang="en-US" sz="1824">
+              <a:rPr sz="1300" b="1" i="0">
                 <a:solidFill>
                   <a:srgbClr val="1E2638"/>
                 </a:solidFill>
-                <a:latin typeface="Calibri (MS)"/>
-                <a:ea typeface="Calibri (MS)"/>
-                <a:cs typeface="Calibri (MS)"/>
-                <a:sym typeface="Calibri (MS)"/>
+                <a:latin typeface="Calibri"/>
               </a:rPr>
-              <a:t>Maximized chances of survival</a:t>
+              <a:t>SURVIVAL MULTIPLIER: </a:t>
+            </a:r>
+            <a:r>
+              <a:rPr sz="1300" b="0" i="0">
+                <a:solidFill>
+                  <a:srgbClr val="3C465A"/>
+                </a:solidFill>
+                <a:latin typeface="Calibri"/>
+              </a:rPr>
+              <a:t>Dramatically cuts time-to-extraction under rubble</a:t>
             </a:r>
           </a:p>
         </p:txBody>
@@ -25943,83 +26174,104 @@
               <a:lnSpc>
                 <a:spcPts val="2189"/>
               </a:lnSpc>
+              <a:spcAft>
+                <a:spcPts val="200"/>
+              </a:spcAft>
               <a:buFont typeface="Arial"/>
               <a:buChar char="•"/>
             </a:pPr>
             <a:r>
-              <a:rPr lang="en-US" sz="1824">
+              <a:rPr sz="1300" b="1" i="0">
                 <a:solidFill>
                   <a:srgbClr val="1E2638"/>
                 </a:solidFill>
-                <a:latin typeface="Calibri (MS)"/>
-                <a:ea typeface="Calibri (MS)"/>
-                <a:cs typeface="Calibri (MS)"/>
-                <a:sym typeface="Calibri (MS)"/>
+                <a:latin typeface="Calibri"/>
               </a:rPr>
-              <a:t>Advance hazard mapping</a:t>
+              <a:t>ADVANCE HAZARD MAPPING: </a:t>
+            </a:r>
+            <a:r>
+              <a:rPr sz="1300" b="0" i="0">
+                <a:solidFill>
+                  <a:srgbClr val="3C465A"/>
+                </a:solidFill>
+                <a:latin typeface="Calibri"/>
+              </a:rPr>
+              <a:t>Flags live high-voltage cables, gas leaks &amp; floodwaters</a:t>
             </a:r>
           </a:p>
           <a:p>
-            <a:pPr algn="l" marL="330279" indent="-165139" lvl="1">
-              <a:lnSpc>
-                <a:spcPts val="2189"/>
-              </a:lnSpc>
-              <a:buFont typeface="Arial"/>
-              <a:buChar char="•"/>
+            <a:pPr>
+              <a:spcAft>
+                <a:spcPts val="200"/>
+              </a:spcAft>
             </a:pPr>
             <a:r>
-              <a:rPr lang="en-US" sz="1824">
+              <a:rPr sz="1300" b="1" i="0">
                 <a:solidFill>
                   <a:srgbClr val="1E2638"/>
                 </a:solidFill>
-                <a:latin typeface="Calibri (MS)"/>
-                <a:ea typeface="Calibri (MS)"/>
-                <a:cs typeface="Calibri (MS)"/>
-                <a:sym typeface="Calibri (MS)"/>
+                <a:latin typeface="Calibri"/>
               </a:rPr>
-              <a:t>Avoid live cables &amp; gas leaks</a:t>
+              <a:t>SAFE ROUTE NAVIGATION: </a:t>
+            </a:r>
+            <a:r>
+              <a:rPr sz="1300" b="0" i="0">
+                <a:solidFill>
+                  <a:srgbClr val="3C465A"/>
+                </a:solidFill>
+                <a:latin typeface="Calibri"/>
+              </a:rPr>
+              <a:t>Dynamic Dijkstra corridor guides rescuers around hazards [1]</a:t>
             </a:r>
           </a:p>
           <a:p>
-            <a:pPr algn="l" marL="330279" indent="-165139" lvl="1">
-              <a:lnSpc>
-                <a:spcPts val="2189"/>
-              </a:lnSpc>
-              <a:buFont typeface="Arial"/>
-              <a:buChar char="•"/>
+            <a:pPr>
+              <a:spcAft>
+                <a:spcPts val="200"/>
+              </a:spcAft>
             </a:pPr>
             <a:r>
-              <a:rPr lang="en-US" sz="1824">
+              <a:rPr sz="1300" b="1" i="0">
                 <a:solidFill>
                   <a:srgbClr val="1E2638"/>
                 </a:solidFill>
-                <a:latin typeface="Calibri (MS)"/>
-                <a:ea typeface="Calibri (MS)"/>
-                <a:cs typeface="Calibri (MS)"/>
-                <a:sym typeface="Calibri (MS)"/>
+                <a:latin typeface="Calibri"/>
               </a:rPr>
-              <a:t>Automated safe-route navigation</a:t>
+              <a:t>TACTICAL AWARENESS: </a:t>
+            </a:r>
+            <a:r>
+              <a:rPr sz="1300" b="0" i="0">
+                <a:solidFill>
+                  <a:srgbClr val="3C465A"/>
+                </a:solidFill>
+                <a:latin typeface="Calibri"/>
+              </a:rPr>
+              <a:t>Crews proceed straight to verified survivor coordinates</a:t>
             </a:r>
           </a:p>
           <a:p>
-            <a:pPr algn="l" marL="330279" indent="-165139" lvl="1">
-              <a:lnSpc>
-                <a:spcPts val="2189"/>
-              </a:lnSpc>
-              <a:buFont typeface="Arial"/>
-              <a:buChar char="•"/>
+            <a:pPr>
+              <a:spcAft>
+                <a:spcPts val="200"/>
+              </a:spcAft>
             </a:pPr>
             <a:r>
-              <a:rPr lang="en-US" sz="1824">
+              <a:rPr sz="1300" b="1" i="0">
                 <a:solidFill>
                   <a:srgbClr val="1E2638"/>
                 </a:solidFill>
-                <a:latin typeface="Calibri (MS)"/>
-                <a:ea typeface="Calibri (MS)"/>
-                <a:cs typeface="Calibri (MS)"/>
-                <a:sym typeface="Calibri (MS)"/>
+                <a:latin typeface="Calibri"/>
               </a:rPr>
-              <a:t>Reduced physical rescuer fatigue</a:t>
+              <a:t>FATIGUE REDUCTION: </a:t>
+            </a:r>
+            <a:r>
+              <a:rPr sz="1300" b="0" i="0">
+                <a:solidFill>
+                  <a:srgbClr val="3C465A"/>
+                </a:solidFill>
+                <a:latin typeface="Calibri"/>
+              </a:rPr>
+              <a:t>Replaces blind shovel digs with targeted extraction</a:t>
             </a:r>
           </a:p>
         </p:txBody>
@@ -26357,83 +26609,104 @@
               <a:lnSpc>
                 <a:spcPts val="2189"/>
               </a:lnSpc>
+              <a:spcAft>
+                <a:spcPts val="200"/>
+              </a:spcAft>
               <a:buFont typeface="Arial"/>
               <a:buChar char="•"/>
             </a:pPr>
             <a:r>
-              <a:rPr lang="en-US" sz="1824">
+              <a:rPr sz="1300" b="1" i="0">
                 <a:solidFill>
                   <a:srgbClr val="1E2638"/>
                 </a:solidFill>
-                <a:latin typeface="Calibri (MS)"/>
-                <a:ea typeface="Calibri (MS)"/>
-                <a:cs typeface="Calibri (MS)"/>
-                <a:sym typeface="Calibri (MS)"/>
+                <a:latin typeface="Calibri"/>
               </a:rPr>
-              <a:t>Unified local tactical map</a:t>
+              <a:t>UNIFIED COMMON PICTURE: </a:t>
+            </a:r>
+            <a:r>
+              <a:rPr sz="1300" b="0" i="0">
+                <a:solidFill>
+                  <a:srgbClr val="3C465A"/>
+                </a:solidFill>
+                <a:latin typeface="Calibri"/>
+              </a:rPr>
+              <a:t>Real-time casualty mapping with micro-telemetry tracking</a:t>
             </a:r>
           </a:p>
           <a:p>
-            <a:pPr algn="l" marL="330279" indent="-165139" lvl="1">
-              <a:lnSpc>
-                <a:spcPts val="2189"/>
-              </a:lnSpc>
-              <a:buFont typeface="Arial"/>
-              <a:buChar char="•"/>
+            <a:pPr>
+              <a:spcAft>
+                <a:spcPts val="200"/>
+              </a:spcAft>
             </a:pPr>
             <a:r>
-              <a:rPr lang="en-US" sz="1824">
+              <a:rPr sz="1300" b="1" i="0">
                 <a:solidFill>
                   <a:srgbClr val="1E2638"/>
                 </a:solidFill>
-                <a:latin typeface="Calibri (MS)"/>
-                <a:ea typeface="Calibri (MS)"/>
-                <a:cs typeface="Calibri (MS)"/>
-                <a:sym typeface="Calibri (MS)"/>
+                <a:latin typeface="Calibri"/>
               </a:rPr>
-              <a:t>Real-time survivor count &amp; coords</a:t>
+              <a:t>ZERO CLOUD DEPENDENCY: </a:t>
+            </a:r>
+            <a:r>
+              <a:rPr sz="1300" b="0" i="0">
+                <a:solidFill>
+                  <a:srgbClr val="3C465A"/>
+                </a:solidFill>
+                <a:latin typeface="Calibri"/>
+              </a:rPr>
+              <a:t>100% operational during complete cellular &amp; power blackouts</a:t>
             </a:r>
           </a:p>
           <a:p>
-            <a:pPr algn="l" marL="330279" indent="-165139" lvl="1">
-              <a:lnSpc>
-                <a:spcPts val="2189"/>
-              </a:lnSpc>
-              <a:buFont typeface="Arial"/>
-              <a:buChar char="•"/>
+            <a:pPr>
+              <a:spcAft>
+                <a:spcPts val="200"/>
+              </a:spcAft>
             </a:pPr>
             <a:r>
-              <a:rPr lang="en-US" sz="1824">
+              <a:rPr sz="1300" b="1" i="0">
                 <a:solidFill>
                   <a:srgbClr val="1E2638"/>
                 </a:solidFill>
-                <a:latin typeface="Calibri (MS)"/>
-                <a:ea typeface="Calibri (MS)"/>
-                <a:cs typeface="Calibri (MS)"/>
-                <a:sym typeface="Calibri (MS)"/>
+                <a:latin typeface="Calibri"/>
               </a:rPr>
-              <a:t>Zero dependency on cell towers</a:t>
+              <a:t>DYNAMIC SECTOR LOGS: </a:t>
+            </a:r>
+            <a:r>
+              <a:rPr sz="1300" b="0" i="0">
+                <a:solidFill>
+                  <a:srgbClr val="3C465A"/>
+                </a:solidFill>
+                <a:latin typeface="Calibri"/>
+              </a:rPr>
+              <a:t>Autonomous coverage tracking ensures no sector is missed</a:t>
             </a:r>
           </a:p>
           <a:p>
-            <a:pPr algn="l" marL="330279" indent="-165139" lvl="1">
-              <a:lnSpc>
-                <a:spcPts val="2189"/>
-              </a:lnSpc>
-              <a:buFont typeface="Arial"/>
-              <a:buChar char="•"/>
+            <a:pPr>
+              <a:spcAft>
+                <a:spcPts val="200"/>
+              </a:spcAft>
             </a:pPr>
             <a:r>
-              <a:rPr lang="en-US" sz="1824">
+              <a:rPr sz="1300" b="1" i="0">
                 <a:solidFill>
                   <a:srgbClr val="1E2638"/>
                 </a:solidFill>
-                <a:latin typeface="Calibri (MS)"/>
-                <a:ea typeface="Calibri (MS)"/>
-                <a:cs typeface="Calibri (MS)"/>
-                <a:sym typeface="Calibri (MS)"/>
+                <a:latin typeface="Calibri"/>
               </a:rPr>
-              <a:t>Dynamic search sector logging</a:t>
+              <a:t>17-BYTE LORA STREAM: </a:t>
+            </a:r>
+            <a:r>
+              <a:rPr sz="1300" b="0" i="0">
+                <a:solidFill>
+                  <a:srgbClr val="3C465A"/>
+                </a:solidFill>
+                <a:latin typeface="Calibri"/>
+              </a:rPr>
+              <a:t>Ultra-compact bit-packed alerts arrive in under 3 seconds [3]</a:t>
             </a:r>
           </a:p>
         </p:txBody>
@@ -26771,83 +27044,104 @@
               <a:lnSpc>
                 <a:spcPts val="2189"/>
               </a:lnSpc>
+              <a:spcAft>
+                <a:spcPts val="200"/>
+              </a:spcAft>
               <a:buFont typeface="Arial"/>
               <a:buChar char="•"/>
             </a:pPr>
             <a:r>
-              <a:rPr lang="en-US" sz="1824">
+              <a:rPr sz="1300" b="1" i="0">
                 <a:solidFill>
                   <a:srgbClr val="1E2638"/>
                 </a:solidFill>
-                <a:latin typeface="Calibri (MS)"/>
-                <a:ea typeface="Calibri (MS)"/>
-                <a:cs typeface="Calibri (MS)"/>
-                <a:sym typeface="Calibri (MS)"/>
+                <a:latin typeface="Calibri"/>
               </a:rPr>
-              <a:t>Efficient resource allocation</a:t>
+              <a:t>TARGETED RESOURCE DROPS: </a:t>
+            </a:r>
+            <a:r>
+              <a:rPr sz="1300" b="0" i="0">
+                <a:solidFill>
+                  <a:srgbClr val="3C465A"/>
+                </a:solidFill>
+                <a:latin typeface="Calibri"/>
+              </a:rPr>
+              <a:t>Prioritized airlift and medical kits based on triage data</a:t>
             </a:r>
           </a:p>
           <a:p>
-            <a:pPr algn="l" marL="330279" indent="-165139" lvl="1">
-              <a:lnSpc>
-                <a:spcPts val="2189"/>
-              </a:lnSpc>
-              <a:buFont typeface="Arial"/>
-              <a:buChar char="•"/>
+            <a:pPr>
+              <a:spcAft>
+                <a:spcPts val="200"/>
+              </a:spcAft>
             </a:pPr>
             <a:r>
-              <a:rPr lang="en-US" sz="1824">
+              <a:rPr sz="1300" b="1" i="0">
                 <a:solidFill>
                   <a:srgbClr val="1E2638"/>
                 </a:solidFill>
-                <a:latin typeface="Calibri (MS)"/>
-                <a:ea typeface="Calibri (MS)"/>
-                <a:cs typeface="Calibri (MS)"/>
-                <a:sym typeface="Calibri (MS)"/>
+                <a:latin typeface="Calibri"/>
               </a:rPr>
-              <a:t>Targeted airlift &amp; medical drops</a:t>
+              <a:t>AFFORDABLE PROCUREMENT: </a:t>
+            </a:r>
+            <a:r>
+              <a:rPr sz="1300" b="0" i="0">
+                <a:solidFill>
+                  <a:srgbClr val="3C465A"/>
+                </a:solidFill>
+                <a:latin typeface="Calibri"/>
+              </a:rPr>
+              <a:t>Deploy 10 Phoenix drones for the price of 1 enterprise UAV</a:t>
             </a:r>
           </a:p>
           <a:p>
-            <a:pPr algn="l" marL="330279" indent="-165139" lvl="1">
-              <a:lnSpc>
-                <a:spcPts val="2189"/>
-              </a:lnSpc>
-              <a:buFont typeface="Arial"/>
-              <a:buChar char="•"/>
+            <a:pPr>
+              <a:spcAft>
+                <a:spcPts val="200"/>
+              </a:spcAft>
             </a:pPr>
             <a:r>
-              <a:rPr lang="en-US" sz="1824">
+              <a:rPr sz="1300" b="1" i="0">
                 <a:solidFill>
                   <a:srgbClr val="1E2638"/>
                 </a:solidFill>
-                <a:latin typeface="Calibri (MS)"/>
-                <a:ea typeface="Calibri (MS)"/>
-                <a:cs typeface="Calibri (MS)"/>
-                <a:sym typeface="Calibri (MS)"/>
+                <a:latin typeface="Calibri"/>
               </a:rPr>
-              <a:t>Post-disaster audit trails</a:t>
+              <a:t>AUDITABLE EVENT LOGS: </a:t>
+            </a:r>
+            <a:r>
+              <a:rPr sz="1300" b="0" i="0">
+                <a:solidFill>
+                  <a:srgbClr val="3C465A"/>
+                </a:solidFill>
+                <a:latin typeface="Calibri"/>
+              </a:rPr>
+              <a:t>Tamper-evident onboard flight logs for post-incident review</a:t>
             </a:r>
           </a:p>
           <a:p>
-            <a:pPr algn="l" marL="330279" indent="-165139" lvl="1">
-              <a:lnSpc>
-                <a:spcPts val="2189"/>
-              </a:lnSpc>
-              <a:buFont typeface="Arial"/>
-              <a:buChar char="•"/>
+            <a:pPr>
+              <a:spcAft>
+                <a:spcPts val="200"/>
+              </a:spcAft>
             </a:pPr>
             <a:r>
-              <a:rPr lang="en-US" sz="1824">
+              <a:rPr sz="1300" b="1" i="0">
                 <a:solidFill>
                   <a:srgbClr val="1E2638"/>
                 </a:solidFill>
-                <a:latin typeface="Calibri (MS)"/>
-                <a:ea typeface="Calibri (MS)"/>
-                <a:cs typeface="Calibri (MS)"/>
-                <a:sym typeface="Calibri (MS)"/>
+                <a:latin typeface="Calibri"/>
               </a:rPr>
-              <a:t>Affordable procurement at scale</a:t>
+              <a:t>SCALABLE STOCKPILING: </a:t>
+            </a:r>
+            <a:r>
+              <a:rPr sz="1300" b="0" i="0">
+                <a:solidFill>
+                  <a:srgbClr val="3C465A"/>
+                </a:solidFill>
+                <a:latin typeface="Calibri"/>
+              </a:rPr>
+              <a:t>Standardized COTS electronics enable rapid state-wide rollout</a:t>
             </a:r>
           </a:p>
         </p:txBody>
@@ -27662,16 +27956,22 @@
               </a:lnSpc>
             </a:pPr>
             <a:r>
-              <a:rPr lang="en-US" sz="1725" b="true">
+              <a:rPr sz="1250" b="1" i="0">
                 <a:solidFill>
                   <a:srgbClr val="1F497D"/>
                 </a:solidFill>
-                <a:latin typeface="Calibri (MS) Bold"/>
-                <a:ea typeface="Calibri (MS) Bold"/>
-                <a:cs typeface="Calibri (MS) Bold"/>
-                <a:sym typeface="Calibri (MS) Bold"/>
+                <a:latin typeface="Calibri"/>
               </a:rPr>
-              <a:t>Backpack to flight with no infrastructure</a:t>
+              <a:t>BACKPACK DEPLOY: </a:t>
+            </a:r>
+            <a:r>
+              <a:rPr sz="1250" b="0" i="0">
+                <a:solidFill>
+                  <a:srgbClr val="3C465A"/>
+                </a:solidFill>
+                <a:latin typeface="Calibri"/>
+              </a:rPr>
+              <a:t>Unbox to autonomous flight in &lt; 3 minutes</a:t>
             </a:r>
           </a:p>
         </p:txBody>
@@ -27703,16 +28003,22 @@
               </a:lnSpc>
             </a:pPr>
             <a:r>
-              <a:rPr lang="en-US" sz="1725">
+              <a:rPr sz="1250" b="1" i="0">
                 <a:solidFill>
                   <a:srgbClr val="1E2638"/>
                 </a:solidFill>
-                <a:latin typeface="Calibri (MS)"/>
-                <a:ea typeface="Calibri (MS)"/>
-                <a:cs typeface="Calibri (MS)"/>
-                <a:sym typeface="Calibri (MS)"/>
+                <a:latin typeface="Calibri"/>
               </a:rPr>
-              <a:t>Search starts within minutes of arrival</a:t>
+              <a:t>ZERO INFRASTRUCTURE: </a:t>
+            </a:r>
+            <a:r>
+              <a:rPr sz="1250" b="0" i="0">
+                <a:solidFill>
+                  <a:srgbClr val="3C465A"/>
+                </a:solidFill>
+                <a:latin typeface="Calibri"/>
+              </a:rPr>
+              <a:t>Search begins immediately upon arrival</a:t>
             </a:r>
           </a:p>
         </p:txBody>
@@ -28174,16 +28480,22 @@
               </a:lnSpc>
             </a:pPr>
             <a:r>
-              <a:rPr lang="en-US" sz="1725" b="true">
+              <a:rPr sz="1250" b="1" i="0">
                 <a:solidFill>
                   <a:srgbClr val="1F497D"/>
                 </a:solidFill>
-                <a:latin typeface="Calibri (MS) Bold"/>
-                <a:ea typeface="Calibri (MS) Bold"/>
-                <a:cs typeface="Calibri (MS) Bold"/>
-                <a:sym typeface="Calibri (MS) Bold"/>
+                <a:latin typeface="Calibri"/>
               </a:rPr>
-              <a:t>Flies an autonomous sweep with RGB + thermal vision</a:t>
+              <a:t>BOUSTROPHEDON SWEEP: </a:t>
+            </a:r>
+            <a:r>
+              <a:rPr sz="1250" b="0" i="0">
+                <a:solidFill>
+                  <a:srgbClr val="3C465A"/>
+                </a:solidFill>
+                <a:latin typeface="Calibri"/>
+              </a:rPr>
+              <a:t>Autonomous dual 1080p + thermal grid coverage</a:t>
             </a:r>
           </a:p>
         </p:txBody>
@@ -28215,16 +28527,22 @@
               </a:lnSpc>
             </a:pPr>
             <a:r>
-              <a:rPr lang="en-US" sz="1725">
+              <a:rPr sz="1250" b="1" i="0">
                 <a:solidFill>
                   <a:srgbClr val="1E2638"/>
                 </a:solidFill>
-                <a:latin typeface="Calibri (MS)"/>
-                <a:ea typeface="Calibri (MS)"/>
-                <a:cs typeface="Calibri (MS)"/>
-                <a:sym typeface="Calibri (MS)"/>
+                <a:latin typeface="Calibri"/>
               </a:rPr>
-              <a:t>Search continues at night and in smoke or fog</a:t>
+              <a:t>ALL-WEATHER SCAN: </a:t>
+            </a:r>
+            <a:r>
+              <a:rPr sz="1250" b="0" i="0">
+                <a:solidFill>
+                  <a:srgbClr val="3C465A"/>
+                </a:solidFill>
+                <a:latin typeface="Calibri"/>
+              </a:rPr>
+              <a:t>Continuous search in smoke, dust &amp; darkness</a:t>
             </a:r>
           </a:p>
         </p:txBody>
@@ -28686,16 +29004,22 @@
               </a:lnSpc>
             </a:pPr>
             <a:r>
-              <a:rPr lang="en-US" sz="1725" b="true">
+              <a:rPr sz="1250" b="1" i="0">
                 <a:solidFill>
                   <a:srgbClr val="1F497D"/>
                 </a:solidFill>
-                <a:latin typeface="Calibri (MS) Bold"/>
-                <a:ea typeface="Calibri (MS) Bold"/>
-                <a:cs typeface="Calibri (MS) Bold"/>
-                <a:sym typeface="Calibri (MS) Bold"/>
+                <a:latin typeface="Calibri"/>
               </a:rPr>
-              <a:t>Pins each detected survivor with GPS coordinates</a:t>
+              <a:t>INSTANT GEOREFERENCING: </a:t>
+            </a:r>
+            <a:r>
+              <a:rPr sz="1250" b="0" i="0">
+                <a:solidFill>
+                  <a:srgbClr val="3C465A"/>
+                </a:solidFill>
+                <a:latin typeface="Calibri"/>
+              </a:rPr>
+              <a:t>Tait-Bryan projection calculates exact ground GPS</a:t>
             </a:r>
           </a:p>
         </p:txBody>
@@ -28727,16 +29051,22 @@
               </a:lnSpc>
             </a:pPr>
             <a:r>
-              <a:rPr lang="en-US" sz="1725">
+              <a:rPr sz="1250" b="1" i="0">
                 <a:solidFill>
                   <a:srgbClr val="1E2638"/>
                 </a:solidFill>
-                <a:latin typeface="Calibri (MS)"/>
-                <a:ea typeface="Calibri (MS)"/>
-                <a:cs typeface="Calibri (MS)"/>
-                <a:sym typeface="Calibri (MS)"/>
+                <a:latin typeface="Calibri"/>
               </a:rPr>
-              <a:t>Rescuers go straight to survivors, not digging blind</a:t>
+              <a:t>ZERO SEARCH DELAY: </a:t>
+            </a:r>
+            <a:r>
+              <a:rPr sz="1250" b="0" i="0">
+                <a:solidFill>
+                  <a:srgbClr val="3C465A"/>
+                </a:solidFill>
+                <a:latin typeface="Calibri"/>
+              </a:rPr>
+              <a:t>Rescuers proceed straight to survivor coordinates</a:t>
             </a:r>
           </a:p>
         </p:txBody>
@@ -29198,16 +29528,22 @@
               </a:lnSpc>
             </a:pPr>
             <a:r>
-              <a:rPr lang="en-US" sz="1725" b="true">
+              <a:rPr sz="1250" b="1" i="0">
                 <a:solidFill>
                   <a:srgbClr val="1F497D"/>
                 </a:solidFill>
-                <a:latin typeface="Calibri (MS) Bold"/>
-                <a:ea typeface="Calibri (MS) Bold"/>
-                <a:cs typeface="Calibri (MS) Bold"/>
-                <a:sym typeface="Calibri (MS) Bold"/>
+                <a:latin typeface="Calibri"/>
               </a:rPr>
-              <a:t>Ranks survivors and plots a hazard-free route</a:t>
+              <a:t>TRIAGE &amp; HAZARD ROUTE: </a:t>
+            </a:r>
+            <a:r>
+              <a:rPr sz="1250" b="0" i="0">
+                <a:solidFill>
+                  <a:srgbClr val="3C465A"/>
+                </a:solidFill>
+                <a:latin typeface="Calibri"/>
+              </a:rPr>
+              <a:t>Ranks casualties &amp; computes Dijkstra safe corridors [1]</a:t>
             </a:r>
           </a:p>
         </p:txBody>
@@ -29239,16 +29575,22 @@
               </a:lnSpc>
             </a:pPr>
             <a:r>
-              <a:rPr lang="en-US" sz="1725">
+              <a:rPr sz="1250" b="1" i="0">
                 <a:solidFill>
                   <a:srgbClr val="1E2638"/>
                 </a:solidFill>
-                <a:latin typeface="Calibri (MS)"/>
-                <a:ea typeface="Calibri (MS)"/>
-                <a:cs typeface="Calibri (MS)"/>
-                <a:sym typeface="Calibri (MS)"/>
+                <a:latin typeface="Calibri"/>
               </a:rPr>
-              <a:t>Crews avoid cave-ins, gas leaks and live cables</a:t>
+              <a:t>CREW PROTECTION: </a:t>
+            </a:r>
+            <a:r>
+              <a:rPr sz="1250" b="0" i="0">
+                <a:solidFill>
+                  <a:srgbClr val="3C465A"/>
+                </a:solidFill>
+                <a:latin typeface="Calibri"/>
+              </a:rPr>
+              <a:t>Rescuers avoid live power cables &amp; gas hazards</a:t>
             </a:r>
           </a:p>
         </p:txBody>
@@ -29710,16 +30052,22 @@
               </a:lnSpc>
             </a:pPr>
             <a:r>
-              <a:rPr lang="en-US" sz="1725" b="true">
+              <a:rPr sz="1250" b="1" i="0">
                 <a:solidFill>
                   <a:srgbClr val="1F497D"/>
                 </a:solidFill>
-                <a:latin typeface="Calibri (MS) Bold"/>
-                <a:ea typeface="Calibri (MS) Bold"/>
-                <a:cs typeface="Calibri (MS) Bold"/>
-                <a:sym typeface="Calibri (MS) Bold"/>
+                <a:latin typeface="Calibri"/>
               </a:rPr>
-              <a:t>Delivers all this at a fraction of enterprise-drone cost</a:t>
+              <a:t>FLEET ECONOMICS: </a:t>
+            </a:r>
+            <a:r>
+              <a:rPr sz="1250" b="0" i="0">
+                <a:solidFill>
+                  <a:srgbClr val="3C465A"/>
+                </a:solidFill>
+                <a:latin typeface="Calibri"/>
+              </a:rPr>
+              <a:t>Full autonomous capability at 1/10th enterprise cost</a:t>
             </a:r>
           </a:p>
         </p:txBody>
@@ -29751,16 +30099,22 @@
               </a:lnSpc>
             </a:pPr>
             <a:r>
-              <a:rPr lang="en-US" sz="1725">
+              <a:rPr sz="1250" b="1" i="0">
                 <a:solidFill>
                   <a:srgbClr val="1E2638"/>
                 </a:solidFill>
-                <a:latin typeface="Calibri (MS)"/>
-                <a:ea typeface="Calibri (MS)"/>
-                <a:cs typeface="Calibri (MS)"/>
-                <a:sym typeface="Calibri (MS)"/>
+                <a:latin typeface="Calibri"/>
               </a:rPr>
-              <a:t>More survivors reached in the Golden 72 hours</a:t>
+              <a:t>LIVES SAVED: </a:t>
+            </a:r>
+            <a:r>
+              <a:rPr sz="1250" b="0" i="0">
+                <a:solidFill>
+                  <a:srgbClr val="3C465A"/>
+                </a:solidFill>
+                <a:latin typeface="Calibri"/>
+              </a:rPr>
+              <a:t>Accelerates extraction within the Golden 72 hours</a:t>
             </a:r>
           </a:p>
         </p:txBody>
@@ -33663,9 +34017,12 @@
               <a:lnSpc>
                 <a:spcPts val="2069"/>
               </a:lnSpc>
+              <a:spcAft>
+                <a:spcPts val="200"/>
+              </a:spcAft>
             </a:pPr>
             <a:r>
-              <a:rPr sz="1650" b="1">
+              <a:rPr sz="1350" b="0" i="0">
                 <a:solidFill>
                   <a:srgbClr val="1E2638"/>
                 </a:solidFill>
@@ -33675,8 +34032,13 @@
             </a:r>
           </a:p>
           <a:p>
+            <a:pPr>
+              <a:spcAft>
+                <a:spcPts val="200"/>
+              </a:spcAft>
+            </a:pPr>
             <a:r>
-              <a:rPr sz="1650" b="1">
+              <a:rPr sz="1350" b="0" i="0">
                 <a:solidFill>
                   <a:srgbClr val="1E2638"/>
                 </a:solidFill>
@@ -33686,8 +34048,13 @@
             </a:r>
           </a:p>
           <a:p>
+            <a:pPr>
+              <a:spcAft>
+                <a:spcPts val="200"/>
+              </a:spcAft>
+            </a:pPr>
             <a:r>
-              <a:rPr sz="1650" b="1">
+              <a:rPr sz="1350" b="0" i="0">
                 <a:solidFill>
                   <a:srgbClr val="1E2638"/>
                 </a:solidFill>
@@ -33697,14 +34064,19 @@
             </a:r>
           </a:p>
           <a:p>
+            <a:pPr>
+              <a:spcAft>
+                <a:spcPts val="200"/>
+              </a:spcAft>
+            </a:pPr>
             <a:r>
-              <a:rPr sz="1650" b="1">
+              <a:rPr sz="1350" b="0" i="0">
                 <a:solidFill>
                   <a:srgbClr val="1E2638"/>
                 </a:solidFill>
                 <a:latin typeface="Calibri"/>
               </a:rPr>
-              <a:t>4. docs/bouabdallah_quadrotor_research_findings.md</a:t>
+              <a:t>4. docs/hardware_viva_defense_guide.md</a:t>
             </a:r>
           </a:p>
         </p:txBody>

</xml_diff>